<commit_message>
Reflect real self-intro (JC career 2016-2026 + SNS×business results)
- Program script & NotebookLM outline: 自己紹介 now uses real timeline (2016 入会
  〜2026) and SNS-to-results proof points (うなぎのぼり/LinkedIn/Threads/福祉満床/
  REAL JAPAN VIBES/障がい者施設).
- Regenerated .pptx to 21 slides: real self-intro + 実績 slide + WHY slides.
</commit_message>
<xml_diff>
--- a/ai_sns_seminar_deck.pptx
+++ b/ai_sns_seminar_deck.pptx
@@ -25,6 +25,7 @@
     <p:sldId id="273" r:id="rId24"/>
     <p:sldId id="274" r:id="rId25"/>
     <p:sldId id="275" r:id="rId26"/>
+    <p:sldId id="276" r:id="rId27"/>
   </p:sldIdLst>
   <p:sldSz cx="12191695" cy="6858000" type="screen4x3"/>
   <p:notesSz cx="6858000" cy="9144000"/>
@@ -3329,7 +3330,7 @@
         <p:spPr>
           <a:xfrm>
             <a:off x="822960" y="5212080"/>
-            <a:ext cx="10515600" cy="548640"/>
+            <a:ext cx="10515600" cy="731520"/>
           </a:xfrm>
           <a:prstGeom prst="rect">
             <a:avLst/>
@@ -3393,6 +3394,50 @@
             <a:avLst/>
           </a:prstGeom>
           <a:solidFill>
+            <a:srgbClr val="F7F5EF"/>
+          </a:solidFill>
+          <a:ln>
+            <a:noFill/>
+          </a:ln>
+          <a:effectLst/>
+        </p:spPr>
+        <p:style>
+          <a:lnRef idx="1">
+            <a:schemeClr val="accent1"/>
+          </a:lnRef>
+          <a:fillRef idx="3">
+            <a:schemeClr val="accent1"/>
+          </a:fillRef>
+          <a:effectRef idx="2">
+            <a:schemeClr val="accent1"/>
+          </a:effectRef>
+          <a:fontRef idx="minor">
+            <a:schemeClr val="lt1"/>
+          </a:fontRef>
+        </p:style>
+        <p:txBody>
+          <a:bodyPr rtlCol="0" anchor="ctr"/>
+          <a:lstStyle/>
+          <a:p>
+            <a:pPr algn="ctr"/>
+          </a:p>
+        </p:txBody>
+      </p:sp>
+      <p:sp>
+        <p:nvSpPr>
+          <p:cNvPr id="3" name="Rectangle 2"/>
+          <p:cNvSpPr/>
+          <p:nvPr/>
+        </p:nvSpPr>
+        <p:spPr>
+          <a:xfrm>
+            <a:off x="0" y="0"/>
+            <a:ext cx="12191695" cy="1371600"/>
+          </a:xfrm>
+          <a:prstGeom prst="rect">
+            <a:avLst/>
+          </a:prstGeom>
+          <a:solidFill>
             <a:srgbClr val="0E1B2E"/>
           </a:solidFill>
           <a:ln>
@@ -3424,14 +3469,14 @@
       </p:sp>
       <p:sp>
         <p:nvSpPr>
-          <p:cNvPr id="3" name="Rectangle 2"/>
+          <p:cNvPr id="4" name="Rectangle 3"/>
           <p:cNvSpPr/>
           <p:nvPr/>
         </p:nvSpPr>
         <p:spPr>
           <a:xfrm>
-            <a:off x="822960" y="2148840"/>
-            <a:ext cx="1280160" cy="82296"/>
+            <a:off x="0" y="1371600"/>
+            <a:ext cx="12191695" cy="54864"/>
           </a:xfrm>
           <a:prstGeom prst="rect">
             <a:avLst/>
@@ -3468,14 +3513,14 @@
       </p:sp>
       <p:sp>
         <p:nvSpPr>
-          <p:cNvPr id="4" name="TextBox 3"/>
+          <p:cNvPr id="5" name="TextBox 4"/>
           <p:cNvSpPr txBox="1"/>
           <p:nvPr/>
         </p:nvSpPr>
         <p:spPr>
           <a:xfrm>
-            <a:off x="822960" y="1417320"/>
-            <a:ext cx="10058400" cy="457200"/>
+            <a:off x="822960" y="310896"/>
+            <a:ext cx="10515600" cy="365760"/>
           </a:xfrm>
           <a:prstGeom prst="rect">
             <a:avLst/>
@@ -3494,28 +3539,28 @@
               </a:spcAft>
             </a:pPr>
             <a:r>
-              <a:rPr sz="1500" b="1">
+              <a:rPr sz="1300" b="1">
                 <a:solidFill>
                   <a:srgbClr val="E3C373"/>
                 </a:solidFill>
                 <a:latin typeface="Yu Gothic"/>
                 <a:ea typeface="Yu Gothic"/>
               </a:rPr>
-              <a:t>10 ｜ 実演1</a:t>
-            </a:r>
-          </a:p>
-        </p:txBody>
-      </p:sp>
-      <p:sp>
-        <p:nvSpPr>
-          <p:cNvPr id="5" name="TextBox 4"/>
+              <a:t>10 ｜ 現在地</a:t>
+            </a:r>
+          </a:p>
+        </p:txBody>
+      </p:sp>
+      <p:sp>
+        <p:nvSpPr>
+          <p:cNvPr id="6" name="TextBox 5"/>
           <p:cNvSpPr txBox="1"/>
           <p:nvPr/>
         </p:nvSpPr>
         <p:spPr>
           <a:xfrm>
-            <a:off x="822960" y="2423160"/>
-            <a:ext cx="10515600" cy="1554480"/>
+            <a:off x="822960" y="676656"/>
+            <a:ext cx="10515600" cy="640080"/>
           </a:xfrm>
           <a:prstGeom prst="rect">
             <a:avLst/>
@@ -3534,28 +3579,28 @@
               </a:spcAft>
             </a:pPr>
             <a:r>
-              <a:rPr sz="3400" b="1">
+              <a:rPr sz="2600" b="1">
                 <a:solidFill>
                   <a:srgbClr val="FFFFFF"/>
                 </a:solidFill>
                 <a:latin typeface="Yu Gothic"/>
                 <a:ea typeface="Yu Gothic"/>
               </a:rPr>
-              <a:t>担当例会をSNS投稿化する</a:t>
-            </a:r>
-          </a:p>
-        </p:txBody>
-      </p:sp>
-      <p:sp>
-        <p:nvSpPr>
-          <p:cNvPr id="6" name="TextBox 5"/>
+              <a:t>AI活用の現在地</a:t>
+            </a:r>
+          </a:p>
+        </p:txBody>
+      </p:sp>
+      <p:sp>
+        <p:nvSpPr>
+          <p:cNvPr id="7" name="TextBox 6"/>
           <p:cNvSpPr txBox="1"/>
           <p:nvPr/>
         </p:nvSpPr>
         <p:spPr>
           <a:xfrm>
-            <a:off x="822960" y="4206240"/>
-            <a:ext cx="10058400" cy="1371600"/>
+            <a:off x="822960" y="1737360"/>
+            <a:ext cx="10515600" cy="548640"/>
           </a:xfrm>
           <a:prstGeom prst="rect">
             <a:avLst/>
@@ -3574,14 +3619,326 @@
               </a:spcAft>
             </a:pPr>
             <a:r>
-              <a:rPr sz="1800" b="0">
-                <a:solidFill>
-                  <a:srgbClr val="CDD5DF"/>
-                </a:solidFill>
-                <a:latin typeface="Yu Gothic"/>
-                <a:ea typeface="Yu Gothic"/>
-              </a:rPr>
-              <a:t>例会情報を入れるだけで、広報素材が一気にそろう</a:t>
+              <a:rPr sz="1800" b="1">
+                <a:solidFill>
+                  <a:srgbClr val="0E1B2E"/>
+                </a:solidFill>
+                <a:latin typeface="Yu Gothic"/>
+                <a:ea typeface="Yu Gothic"/>
+              </a:rPr>
+              <a:t>役割ごとに使い分ける時代</a:t>
+            </a:r>
+          </a:p>
+        </p:txBody>
+      </p:sp>
+      <p:sp>
+        <p:nvSpPr>
+          <p:cNvPr id="8" name="TextBox 7"/>
+          <p:cNvSpPr txBox="1"/>
+          <p:nvPr/>
+        </p:nvSpPr>
+        <p:spPr>
+          <a:xfrm>
+            <a:off x="868680" y="2514600"/>
+            <a:ext cx="5212080" cy="365760"/>
+          </a:xfrm>
+          <a:prstGeom prst="rect">
+            <a:avLst/>
+          </a:prstGeom>
+          <a:noFill/>
+        </p:spPr>
+        <p:txBody>
+          <a:bodyPr wrap="square" anchor="t" lIns="0" rIns="0" tIns="0" bIns="0">
+            <a:spAutoFit/>
+          </a:bodyPr>
+          <a:lstStyle/>
+          <a:p>
+            <a:pPr algn="l">
+              <a:spcAft>
+                <a:spcPts val="0"/>
+              </a:spcAft>
+            </a:pPr>
+            <a:r>
+              <a:rPr sz="1500" b="1">
+                <a:solidFill>
+                  <a:srgbClr val="C9A24B"/>
+                </a:solidFill>
+                <a:latin typeface="Yu Gothic"/>
+                <a:ea typeface="Yu Gothic"/>
+              </a:rPr>
+              <a:t>対話・文章・整理</a:t>
+            </a:r>
+          </a:p>
+        </p:txBody>
+      </p:sp>
+      <p:sp>
+        <p:nvSpPr>
+          <p:cNvPr id="9" name="TextBox 8"/>
+          <p:cNvSpPr txBox="1"/>
+          <p:nvPr/>
+        </p:nvSpPr>
+        <p:spPr>
+          <a:xfrm>
+            <a:off x="960120" y="2926080"/>
+            <a:ext cx="5120640" cy="3200400"/>
+          </a:xfrm>
+          <a:prstGeom prst="rect">
+            <a:avLst/>
+          </a:prstGeom>
+          <a:noFill/>
+        </p:spPr>
+        <p:txBody>
+          <a:bodyPr wrap="square" anchor="t" lIns="0" rIns="0" tIns="0" bIns="0">
+            <a:spAutoFit/>
+          </a:bodyPr>
+          <a:lstStyle/>
+          <a:p>
+            <a:pPr algn="l">
+              <a:spcAft>
+                <a:spcPts val="800"/>
+              </a:spcAft>
+            </a:pPr>
+            <a:r>
+              <a:rPr sz="1500" b="0">
+                <a:solidFill>
+                  <a:srgbClr val="222A35"/>
+                </a:solidFill>
+                <a:latin typeface="Yu Gothic"/>
+                <a:ea typeface="Yu Gothic"/>
+              </a:rPr>
+              <a:t>●  ChatGPT：相談・文章・企画・壁打ち</a:t>
+            </a:r>
+          </a:p>
+          <a:p>
+            <a:pPr algn="l">
+              <a:spcAft>
+                <a:spcPts val="800"/>
+              </a:spcAft>
+            </a:pPr>
+            <a:r>
+              <a:rPr sz="1500" b="0">
+                <a:solidFill>
+                  <a:srgbClr val="222A35"/>
+                </a:solidFill>
+                <a:latin typeface="Yu Gothic"/>
+                <a:ea typeface="Yu Gothic"/>
+              </a:rPr>
+              <a:t>●  Claude：長文整理・資料構成</a:t>
+            </a:r>
+          </a:p>
+          <a:p>
+            <a:pPr algn="l">
+              <a:spcAft>
+                <a:spcPts val="800"/>
+              </a:spcAft>
+            </a:pPr>
+            <a:r>
+              <a:rPr sz="1500" b="0">
+                <a:solidFill>
+                  <a:srgbClr val="222A35"/>
+                </a:solidFill>
+                <a:latin typeface="Yu Gothic"/>
+                <a:ea typeface="Yu Gothic"/>
+              </a:rPr>
+              <a:t>●  NotebookLM：資料だけで正確に整理</a:t>
+            </a:r>
+          </a:p>
+        </p:txBody>
+      </p:sp>
+      <p:sp>
+        <p:nvSpPr>
+          <p:cNvPr id="10" name="TextBox 9"/>
+          <p:cNvSpPr txBox="1"/>
+          <p:nvPr/>
+        </p:nvSpPr>
+        <p:spPr>
+          <a:xfrm>
+            <a:off x="6355080" y="2514600"/>
+            <a:ext cx="5029200" cy="365760"/>
+          </a:xfrm>
+          <a:prstGeom prst="rect">
+            <a:avLst/>
+          </a:prstGeom>
+          <a:noFill/>
+        </p:spPr>
+        <p:txBody>
+          <a:bodyPr wrap="square" anchor="t" lIns="0" rIns="0" tIns="0" bIns="0">
+            <a:spAutoFit/>
+          </a:bodyPr>
+          <a:lstStyle/>
+          <a:p>
+            <a:pPr algn="l">
+              <a:spcAft>
+                <a:spcPts val="0"/>
+              </a:spcAft>
+            </a:pPr>
+            <a:r>
+              <a:rPr sz="1500" b="1">
+                <a:solidFill>
+                  <a:srgbClr val="C9A24B"/>
+                </a:solidFill>
+                <a:latin typeface="Yu Gothic"/>
+                <a:ea typeface="Yu Gothic"/>
+              </a:rPr>
+              <a:t>ビジュアル・蓄積</a:t>
+            </a:r>
+          </a:p>
+        </p:txBody>
+      </p:sp>
+      <p:sp>
+        <p:nvSpPr>
+          <p:cNvPr id="11" name="TextBox 10"/>
+          <p:cNvSpPr txBox="1"/>
+          <p:nvPr/>
+        </p:nvSpPr>
+        <p:spPr>
+          <a:xfrm>
+            <a:off x="6446520" y="2926080"/>
+            <a:ext cx="4937760" cy="3200400"/>
+          </a:xfrm>
+          <a:prstGeom prst="rect">
+            <a:avLst/>
+          </a:prstGeom>
+          <a:noFill/>
+        </p:spPr>
+        <p:txBody>
+          <a:bodyPr wrap="square" anchor="t" lIns="0" rIns="0" tIns="0" bIns="0">
+            <a:spAutoFit/>
+          </a:bodyPr>
+          <a:lstStyle/>
+          <a:p>
+            <a:pPr algn="l">
+              <a:spcAft>
+                <a:spcPts val="800"/>
+              </a:spcAft>
+            </a:pPr>
+            <a:r>
+              <a:rPr sz="1500" b="0">
+                <a:solidFill>
+                  <a:srgbClr val="222A35"/>
+                </a:solidFill>
+                <a:latin typeface="Yu Gothic"/>
+                <a:ea typeface="Yu Gothic"/>
+              </a:rPr>
+              <a:t>●  画像生成：SNS素材・告知</a:t>
+            </a:r>
+          </a:p>
+          <a:p>
+            <a:pPr algn="l">
+              <a:spcAft>
+                <a:spcPts val="800"/>
+              </a:spcAft>
+            </a:pPr>
+            <a:r>
+              <a:rPr sz="1500" b="0">
+                <a:solidFill>
+                  <a:srgbClr val="222A35"/>
+                </a:solidFill>
+                <a:latin typeface="Yu Gothic"/>
+                <a:ea typeface="Yu Gothic"/>
+              </a:rPr>
+              <a:t>●  動画生成：ショート・PR</a:t>
+            </a:r>
+          </a:p>
+          <a:p>
+            <a:pPr algn="l">
+              <a:spcAft>
+                <a:spcPts val="800"/>
+              </a:spcAft>
+            </a:pPr>
+            <a:r>
+              <a:rPr sz="1500" b="0">
+                <a:solidFill>
+                  <a:srgbClr val="222A35"/>
+                </a:solidFill>
+                <a:latin typeface="Yu Gothic"/>
+                <a:ea typeface="Yu Gothic"/>
+              </a:rPr>
+              <a:t>●  Drive/Notion：共有・資産化</a:t>
+            </a:r>
+          </a:p>
+        </p:txBody>
+      </p:sp>
+      <p:sp>
+        <p:nvSpPr>
+          <p:cNvPr id="12" name="Rectangle 11"/>
+          <p:cNvSpPr/>
+          <p:nvPr/>
+        </p:nvSpPr>
+        <p:spPr>
+          <a:xfrm>
+            <a:off x="0" y="6565392"/>
+            <a:ext cx="12191695" cy="292608"/>
+          </a:xfrm>
+          <a:prstGeom prst="rect">
+            <a:avLst/>
+          </a:prstGeom>
+          <a:solidFill>
+            <a:srgbClr val="0E1B2E"/>
+          </a:solidFill>
+          <a:ln>
+            <a:noFill/>
+          </a:ln>
+          <a:effectLst/>
+        </p:spPr>
+        <p:style>
+          <a:lnRef idx="1">
+            <a:schemeClr val="accent1"/>
+          </a:lnRef>
+          <a:fillRef idx="3">
+            <a:schemeClr val="accent1"/>
+          </a:fillRef>
+          <a:effectRef idx="2">
+            <a:schemeClr val="accent1"/>
+          </a:effectRef>
+          <a:fontRef idx="minor">
+            <a:schemeClr val="lt1"/>
+          </a:fontRef>
+        </p:style>
+        <p:txBody>
+          <a:bodyPr rtlCol="0" anchor="ctr"/>
+          <a:lstStyle/>
+          <a:p>
+            <a:pPr algn="ctr"/>
+          </a:p>
+        </p:txBody>
+      </p:sp>
+      <p:sp>
+        <p:nvSpPr>
+          <p:cNvPr id="13" name="TextBox 12"/>
+          <p:cNvSpPr txBox="1"/>
+          <p:nvPr/>
+        </p:nvSpPr>
+        <p:spPr>
+          <a:xfrm>
+            <a:off x="822960" y="6583680"/>
+            <a:ext cx="10515600" cy="256032"/>
+          </a:xfrm>
+          <a:prstGeom prst="rect">
+            <a:avLst/>
+          </a:prstGeom>
+          <a:noFill/>
+        </p:spPr>
+        <p:txBody>
+          <a:bodyPr wrap="square" anchor="t" lIns="0" rIns="0" tIns="0" bIns="0">
+            <a:spAutoFit/>
+          </a:bodyPr>
+          <a:lstStyle/>
+          <a:p>
+            <a:pPr algn="l">
+              <a:spcAft>
+                <a:spcPts val="0"/>
+              </a:spcAft>
+            </a:pPr>
+            <a:r>
+              <a:rPr sz="1000" b="0">
+                <a:solidFill>
+                  <a:srgbClr val="9FADBD"/>
+                </a:solidFill>
+                <a:latin typeface="Yu Gothic"/>
+                <a:ea typeface="Yu Gothic"/>
+              </a:rPr>
+              <a:t>名古屋JC SNS戦略部会 ｜ AIは、使った人から変わっていく</a:t>
             </a:r>
           </a:p>
         </p:txBody>
@@ -3771,7 +4128,7 @@
                 <a:latin typeface="Yu Gothic"/>
                 <a:ea typeface="Yu Gothic"/>
               </a:rPr>
-              <a:t>11 ｜ 実演1</a:t>
+              <a:t>11 ｜ 使い分け</a:t>
             </a:r>
           </a:p>
         </p:txBody>
@@ -3811,7 +4168,7 @@
                 <a:latin typeface="Yu Gothic"/>
                 <a:ea typeface="Yu Gothic"/>
               </a:rPr>
-              <a:t>例会情報から作れるもの</a:t>
+              <a:t>AIは役割で使い分ける</a:t>
             </a:r>
           </a:p>
         </p:txBody>
@@ -3824,8 +4181,8 @@
         </p:nvSpPr>
         <p:spPr>
           <a:xfrm>
-            <a:off x="1005840" y="2834640"/>
-            <a:ext cx="10058400" cy="3291840"/>
+            <a:off x="822960" y="1783080"/>
+            <a:ext cx="10515600" cy="822960"/>
           </a:xfrm>
           <a:prstGeom prst="rect">
             <a:avLst/>
@@ -3840,7 +4197,47 @@
           <a:p>
             <a:pPr algn="l">
               <a:spcAft>
-                <a:spcPts val="1000"/>
+                <a:spcPts val="0"/>
+              </a:spcAft>
+            </a:pPr>
+            <a:r>
+              <a:rPr sz="2000" b="1">
+                <a:solidFill>
+                  <a:srgbClr val="0E1B2E"/>
+                </a:solidFill>
+                <a:latin typeface="Yu Gothic"/>
+                <a:ea typeface="Yu Gothic"/>
+              </a:rPr>
+              <a:t>秘書・編集者・広報・企画補佐・壁打ち相手</a:t>
+            </a:r>
+          </a:p>
+        </p:txBody>
+      </p:sp>
+      <p:sp>
+        <p:nvSpPr>
+          <p:cNvPr id="8" name="TextBox 7"/>
+          <p:cNvSpPr txBox="1"/>
+          <p:nvPr/>
+        </p:nvSpPr>
+        <p:spPr>
+          <a:xfrm>
+            <a:off x="1005840" y="2697480"/>
+            <a:ext cx="10058400" cy="3246120"/>
+          </a:xfrm>
+          <a:prstGeom prst="rect">
+            <a:avLst/>
+          </a:prstGeom>
+          <a:noFill/>
+        </p:spPr>
+        <p:txBody>
+          <a:bodyPr wrap="square" anchor="t" lIns="0" rIns="0" tIns="0" bIns="0">
+            <a:spAutoFit/>
+          </a:bodyPr>
+          <a:lstStyle/>
+          <a:p>
+            <a:pPr algn="l">
+              <a:spcAft>
+                <a:spcPts val="900"/>
               </a:spcAft>
             </a:pPr>
             <a:r>
@@ -3851,13 +4248,13 @@
                 <a:latin typeface="Yu Gothic"/>
                 <a:ea typeface="Yu Gothic"/>
               </a:rPr>
-              <a:t>●  SNS投稿文／ストーリーズ／リール台本</a:t>
-            </a:r>
-          </a:p>
-          <a:p>
-            <a:pPr algn="l">
-              <a:spcAft>
-                <a:spcPts val="1000"/>
+              <a:t>●  秘書：予定・タスク・連絡の整理</a:t>
+            </a:r>
+          </a:p>
+          <a:p>
+            <a:pPr algn="l">
+              <a:spcAft>
+                <a:spcPts val="900"/>
               </a:spcAft>
             </a:pPr>
             <a:r>
@@ -3868,13 +4265,13 @@
                 <a:latin typeface="Yu Gothic"/>
                 <a:ea typeface="Yu Gothic"/>
               </a:rPr>
-              <a:t>●  告知タイトル／ハッシュタグ／参加を促す一言</a:t>
-            </a:r>
-          </a:p>
-          <a:p>
-            <a:pPr algn="l">
-              <a:spcAft>
-                <a:spcPts val="1000"/>
+              <a:t>●  編集者：文章を整える</a:t>
+            </a:r>
+          </a:p>
+          <a:p>
+            <a:pPr algn="l">
+              <a:spcAft>
+                <a:spcPts val="900"/>
               </a:spcAft>
             </a:pPr>
             <a:r>
@@ -3885,14 +4282,31 @@
                 <a:latin typeface="Yu Gothic"/>
                 <a:ea typeface="Yu Gothic"/>
               </a:rPr>
-              <a:t>●  委員会への依頼文／写真・動画の撮影指示</a:t>
-            </a:r>
-          </a:p>
-        </p:txBody>
-      </p:sp>
-      <p:sp>
-        <p:nvSpPr>
-          <p:cNvPr id="8" name="Rectangle 7"/>
+              <a:t>●  広報担当：投稿・告知を作る</a:t>
+            </a:r>
+          </a:p>
+          <a:p>
+            <a:pPr algn="l">
+              <a:spcAft>
+                <a:spcPts val="900"/>
+              </a:spcAft>
+            </a:pPr>
+            <a:r>
+              <a:rPr sz="1600" b="0">
+                <a:solidFill>
+                  <a:srgbClr val="222A35"/>
+                </a:solidFill>
+                <a:latin typeface="Yu Gothic"/>
+                <a:ea typeface="Yu Gothic"/>
+              </a:rPr>
+              <a:t>●  企画補佐／壁打ち：アイデアを広げる</a:t>
+            </a:r>
+          </a:p>
+        </p:txBody>
+      </p:sp>
+      <p:sp>
+        <p:nvSpPr>
+          <p:cNvPr id="9" name="Rectangle 8"/>
           <p:cNvSpPr/>
           <p:nvPr/>
         </p:nvSpPr>
@@ -3936,7 +4350,7 @@
       </p:sp>
       <p:sp>
         <p:nvSpPr>
-          <p:cNvPr id="9" name="TextBox 8"/>
+          <p:cNvPr id="10" name="TextBox 9"/>
           <p:cNvSpPr txBox="1"/>
           <p:nvPr/>
         </p:nvSpPr>
@@ -4115,7 +4529,7 @@
                 <a:latin typeface="Yu Gothic"/>
                 <a:ea typeface="Yu Gothic"/>
               </a:rPr>
-              <a:t>12 ｜ 実演2</a:t>
+              <a:t>12 ｜ 実演1</a:t>
             </a:r>
           </a:p>
         </p:txBody>
@@ -4155,7 +4569,7 @@
                 <a:latin typeface="Yu Gothic"/>
                 <a:ea typeface="Yu Gothic"/>
               </a:rPr>
-              <a:t>画像・動画生成プロンプト</a:t>
+              <a:t>担当例会をSNS投稿化する</a:t>
             </a:r>
           </a:p>
         </p:txBody>
@@ -4195,7 +4609,7 @@
                 <a:latin typeface="Yu Gothic"/>
                 <a:ea typeface="Yu Gothic"/>
               </a:rPr>
-              <a:t>必要なのは“世界観を言語化する力”</a:t>
+              <a:t>例会情報を入れるだけで、広報素材が一気にそろう</a:t>
             </a:r>
           </a:p>
         </p:txBody>
@@ -4385,7 +4799,7 @@
                 <a:latin typeface="Yu Gothic"/>
                 <a:ea typeface="Yu Gothic"/>
               </a:rPr>
-              <a:t>13 ｜ 実演2</a:t>
+              <a:t>13 ｜ 実演1</a:t>
             </a:r>
           </a:p>
         </p:txBody>
@@ -4425,7 +4839,7 @@
                 <a:latin typeface="Yu Gothic"/>
                 <a:ea typeface="Yu Gothic"/>
               </a:rPr>
-              <a:t>日本語と英語プロンプトの違い</a:t>
+              <a:t>例会情報から作れるもの</a:t>
             </a:r>
           </a:p>
         </p:txBody>
@@ -4438,8 +4852,8 @@
         </p:nvSpPr>
         <p:spPr>
           <a:xfrm>
-            <a:off x="822960" y="1783080"/>
-            <a:ext cx="10515600" cy="822960"/>
+            <a:off x="1005840" y="1783080"/>
+            <a:ext cx="10058400" cy="4160520"/>
           </a:xfrm>
           <a:prstGeom prst="rect">
             <a:avLst/>
@@ -4454,47 +4868,7 @@
           <a:p>
             <a:pPr algn="l">
               <a:spcAft>
-                <a:spcPts val="0"/>
-              </a:spcAft>
-            </a:pPr>
-            <a:r>
-              <a:rPr sz="2000" b="1">
-                <a:solidFill>
-                  <a:srgbClr val="0E1B2E"/>
-                </a:solidFill>
-                <a:latin typeface="Yu Gothic"/>
-                <a:ea typeface="Yu Gothic"/>
-              </a:rPr>
-              <a:t>世界観をどう言語化するか</a:t>
-            </a:r>
-          </a:p>
-        </p:txBody>
-      </p:sp>
-      <p:sp>
-        <p:nvSpPr>
-          <p:cNvPr id="8" name="TextBox 7"/>
-          <p:cNvSpPr txBox="1"/>
-          <p:nvPr/>
-        </p:nvSpPr>
-        <p:spPr>
-          <a:xfrm>
-            <a:off x="1005840" y="2834640"/>
-            <a:ext cx="10058400" cy="3291840"/>
-          </a:xfrm>
-          <a:prstGeom prst="rect">
-            <a:avLst/>
-          </a:prstGeom>
-          <a:noFill/>
-        </p:spPr>
-        <p:txBody>
-          <a:bodyPr wrap="square" anchor="t" lIns="0" rIns="0" tIns="0" bIns="0">
-            <a:spAutoFit/>
-          </a:bodyPr>
-          <a:lstStyle/>
-          <a:p>
-            <a:pPr algn="l">
-              <a:spcAft>
-                <a:spcPts val="1000"/>
+                <a:spcPts val="900"/>
               </a:spcAft>
             </a:pPr>
             <a:r>
@@ -4505,13 +4879,13 @@
                 <a:latin typeface="Yu Gothic"/>
                 <a:ea typeface="Yu Gothic"/>
               </a:rPr>
-              <a:t>●  まず「何を感じてほしいか」を1行で決める</a:t>
-            </a:r>
-          </a:p>
-          <a:p>
-            <a:pPr algn="l">
-              <a:spcAft>
-                <a:spcPts val="1000"/>
+              <a:t>●  SNS投稿文／ストーリーズ／リール台本</a:t>
+            </a:r>
+          </a:p>
+          <a:p>
+            <a:pPr algn="l">
+              <a:spcAft>
+                <a:spcPts val="900"/>
               </a:spcAft>
             </a:pPr>
             <a:r>
@@ -4522,13 +4896,13 @@
                 <a:latin typeface="Yu Gothic"/>
                 <a:ea typeface="Yu Gothic"/>
               </a:rPr>
-              <a:t>●  日本語で意図 → 英語プロンプトに変換</a:t>
-            </a:r>
-          </a:p>
-          <a:p>
-            <a:pPr algn="l">
-              <a:spcAft>
-                <a:spcPts val="1000"/>
+              <a:t>●  告知タイトル／ハッシュタグ／参加を促す一言</a:t>
+            </a:r>
+          </a:p>
+          <a:p>
+            <a:pPr algn="l">
+              <a:spcAft>
+                <a:spcPts val="900"/>
               </a:spcAft>
             </a:pPr>
             <a:r>
@@ -4539,14 +4913,14 @@
                 <a:latin typeface="Yu Gothic"/>
                 <a:ea typeface="Yu Gothic"/>
               </a:rPr>
-              <a:t>●  告知画像・15秒ショート・9:16縦型</a:t>
-            </a:r>
-          </a:p>
-        </p:txBody>
-      </p:sp>
-      <p:sp>
-        <p:nvSpPr>
-          <p:cNvPr id="9" name="Rectangle 8"/>
+              <a:t>●  委員会への依頼文／写真・動画の撮影指示</a:t>
+            </a:r>
+          </a:p>
+        </p:txBody>
+      </p:sp>
+      <p:sp>
+        <p:nvSpPr>
+          <p:cNvPr id="8" name="Rectangle 7"/>
           <p:cNvSpPr/>
           <p:nvPr/>
         </p:nvSpPr>
@@ -4590,7 +4964,7 @@
       </p:sp>
       <p:sp>
         <p:nvSpPr>
-          <p:cNvPr id="10" name="TextBox 9"/>
+          <p:cNvPr id="9" name="TextBox 8"/>
           <p:cNvSpPr txBox="1"/>
           <p:nvPr/>
         </p:nvSpPr>
@@ -4769,7 +5143,7 @@
                 <a:latin typeface="Yu Gothic"/>
                 <a:ea typeface="Yu Gothic"/>
               </a:rPr>
-              <a:t>14 ｜ 実演3</a:t>
+              <a:t>14 ｜ 実演2</a:t>
             </a:r>
           </a:p>
         </p:txBody>
@@ -4809,7 +5183,7 @@
                 <a:latin typeface="Yu Gothic"/>
                 <a:ea typeface="Yu Gothic"/>
               </a:rPr>
-              <a:t>AI秘書・ショートカット・スキル活用</a:t>
+              <a:t>画像・動画生成プロンプト</a:t>
             </a:r>
           </a:p>
         </p:txBody>
@@ -4849,7 +5223,7 @@
                 <a:latin typeface="Yu Gothic"/>
                 <a:ea typeface="Yu Gothic"/>
               </a:rPr>
-              <a:t>日々の業務・JC活動全体にAIを使う</a:t>
+              <a:t>必要なのは“世界観を言語化する力”</a:t>
             </a:r>
           </a:p>
         </p:txBody>
@@ -5039,7 +5413,7 @@
                 <a:latin typeface="Yu Gothic"/>
                 <a:ea typeface="Yu Gothic"/>
               </a:rPr>
-              <a:t>15 ｜ 資産化</a:t>
+              <a:t>15 ｜ 実演2</a:t>
             </a:r>
           </a:p>
         </p:txBody>
@@ -5079,7 +5453,7 @@
                 <a:latin typeface="Yu Gothic"/>
                 <a:ea typeface="Yu Gothic"/>
               </a:rPr>
-              <a:t>プロンプトは組織の資産になる</a:t>
+              <a:t>日本語と英語プロンプトの違い</a:t>
             </a:r>
           </a:p>
         </p:txBody>
@@ -5119,7 +5493,7 @@
                 <a:latin typeface="Yu Gothic"/>
                 <a:ea typeface="Yu Gothic"/>
               </a:rPr>
-              <a:t>Google Driveで共有する</a:t>
+              <a:t>世界観をどう言語化するか</a:t>
             </a:r>
           </a:p>
         </p:txBody>
@@ -5132,8 +5506,8 @@
         </p:nvSpPr>
         <p:spPr>
           <a:xfrm>
-            <a:off x="1005840" y="2834640"/>
-            <a:ext cx="10058400" cy="3291840"/>
+            <a:off x="1005840" y="2697480"/>
+            <a:ext cx="10058400" cy="3246120"/>
           </a:xfrm>
           <a:prstGeom prst="rect">
             <a:avLst/>
@@ -5148,7 +5522,7 @@
           <a:p>
             <a:pPr algn="l">
               <a:spcAft>
-                <a:spcPts val="1000"/>
+                <a:spcPts val="900"/>
               </a:spcAft>
             </a:pPr>
             <a:r>
@@ -5159,13 +5533,13 @@
                 <a:latin typeface="Yu Gothic"/>
                 <a:ea typeface="Yu Gothic"/>
               </a:rPr>
-              <a:t>●  一回使って終わりにしない</a:t>
-            </a:r>
-          </a:p>
-          <a:p>
-            <a:pPr algn="l">
-              <a:spcAft>
-                <a:spcPts val="1000"/>
+              <a:t>●  まず「何を感じてほしいか」を1行で決める</a:t>
+            </a:r>
+          </a:p>
+          <a:p>
+            <a:pPr algn="l">
+              <a:spcAft>
+                <a:spcPts val="900"/>
               </a:spcAft>
             </a:pPr>
             <a:r>
@@ -5176,13 +5550,13 @@
                 <a:latin typeface="Yu Gothic"/>
                 <a:ea typeface="Yu Gothic"/>
               </a:rPr>
-              <a:t>●  よく使うものは“型”にする</a:t>
-            </a:r>
-          </a:p>
-          <a:p>
-            <a:pPr algn="l">
-              <a:spcAft>
-                <a:spcPts val="1000"/>
+              <a:t>●  日本語で意図 → 英語プロンプトに変換</a:t>
+            </a:r>
+          </a:p>
+          <a:p>
+            <a:pPr algn="l">
+              <a:spcAft>
+                <a:spcPts val="900"/>
               </a:spcAft>
             </a:pPr>
             <a:r>
@@ -5193,7 +5567,7 @@
                 <a:latin typeface="Yu Gothic"/>
                 <a:ea typeface="Yu Gothic"/>
               </a:rPr>
-              <a:t>●  型にすると、個人のスキルが組織の資産に</a:t>
+              <a:t>●  告知画像・15秒ショート・9:16縦型</a:t>
             </a:r>
           </a:p>
         </p:txBody>
@@ -5315,50 +5689,6 @@
             <a:avLst/>
           </a:prstGeom>
           <a:solidFill>
-            <a:srgbClr val="F7F5EF"/>
-          </a:solidFill>
-          <a:ln>
-            <a:noFill/>
-          </a:ln>
-          <a:effectLst/>
-        </p:spPr>
-        <p:style>
-          <a:lnRef idx="1">
-            <a:schemeClr val="accent1"/>
-          </a:lnRef>
-          <a:fillRef idx="3">
-            <a:schemeClr val="accent1"/>
-          </a:fillRef>
-          <a:effectRef idx="2">
-            <a:schemeClr val="accent1"/>
-          </a:effectRef>
-          <a:fontRef idx="minor">
-            <a:schemeClr val="lt1"/>
-          </a:fontRef>
-        </p:style>
-        <p:txBody>
-          <a:bodyPr rtlCol="0" anchor="ctr"/>
-          <a:lstStyle/>
-          <a:p>
-            <a:pPr algn="ctr"/>
-          </a:p>
-        </p:txBody>
-      </p:sp>
-      <p:sp>
-        <p:nvSpPr>
-          <p:cNvPr id="3" name="Rectangle 2"/>
-          <p:cNvSpPr/>
-          <p:nvPr/>
-        </p:nvSpPr>
-        <p:spPr>
-          <a:xfrm>
-            <a:off x="0" y="0"/>
-            <a:ext cx="12191695" cy="1371600"/>
-          </a:xfrm>
-          <a:prstGeom prst="rect">
-            <a:avLst/>
-          </a:prstGeom>
-          <a:solidFill>
             <a:srgbClr val="0E1B2E"/>
           </a:solidFill>
           <a:ln>
@@ -5390,14 +5720,14 @@
       </p:sp>
       <p:sp>
         <p:nvSpPr>
-          <p:cNvPr id="4" name="Rectangle 3"/>
+          <p:cNvPr id="3" name="Rectangle 2"/>
           <p:cNvSpPr/>
           <p:nvPr/>
         </p:nvSpPr>
         <p:spPr>
           <a:xfrm>
-            <a:off x="0" y="1371600"/>
-            <a:ext cx="12191695" cy="54864"/>
+            <a:off x="822960" y="2148840"/>
+            <a:ext cx="1280160" cy="82296"/>
           </a:xfrm>
           <a:prstGeom prst="rect">
             <a:avLst/>
@@ -5434,14 +5764,14 @@
       </p:sp>
       <p:sp>
         <p:nvSpPr>
-          <p:cNvPr id="5" name="TextBox 4"/>
+          <p:cNvPr id="4" name="TextBox 3"/>
           <p:cNvSpPr txBox="1"/>
           <p:nvPr/>
         </p:nvSpPr>
         <p:spPr>
           <a:xfrm>
-            <a:off x="822960" y="310896"/>
-            <a:ext cx="10515600" cy="365760"/>
+            <a:off x="822960" y="1417320"/>
+            <a:ext cx="10058400" cy="457200"/>
           </a:xfrm>
           <a:prstGeom prst="rect">
             <a:avLst/>
@@ -5460,28 +5790,28 @@
               </a:spcAft>
             </a:pPr>
             <a:r>
-              <a:rPr sz="1300" b="1">
+              <a:rPr sz="1500" b="1">
                 <a:solidFill>
                   <a:srgbClr val="E3C373"/>
                 </a:solidFill>
                 <a:latin typeface="Yu Gothic"/>
                 <a:ea typeface="Yu Gothic"/>
               </a:rPr>
-              <a:t>16 ｜ 注意点</a:t>
-            </a:r>
-          </a:p>
-        </p:txBody>
-      </p:sp>
-      <p:sp>
-        <p:nvSpPr>
-          <p:cNvPr id="6" name="TextBox 5"/>
+              <a:t>16 ｜ 実演3</a:t>
+            </a:r>
+          </a:p>
+        </p:txBody>
+      </p:sp>
+      <p:sp>
+        <p:nvSpPr>
+          <p:cNvPr id="5" name="TextBox 4"/>
           <p:cNvSpPr txBox="1"/>
           <p:nvPr/>
         </p:nvSpPr>
         <p:spPr>
           <a:xfrm>
-            <a:off x="822960" y="676656"/>
-            <a:ext cx="10515600" cy="640080"/>
+            <a:off x="822960" y="2423160"/>
+            <a:ext cx="10515600" cy="1554480"/>
           </a:xfrm>
           <a:prstGeom prst="rect">
             <a:avLst/>
@@ -5500,28 +5830,28 @@
               </a:spcAft>
             </a:pPr>
             <a:r>
-              <a:rPr sz="2600" b="1">
+              <a:rPr sz="3400" b="1">
                 <a:solidFill>
                   <a:srgbClr val="FFFFFF"/>
                 </a:solidFill>
                 <a:latin typeface="Yu Gothic"/>
                 <a:ea typeface="Yu Gothic"/>
               </a:rPr>
-              <a:t>AI活用の注意点</a:t>
-            </a:r>
-          </a:p>
-        </p:txBody>
-      </p:sp>
-      <p:sp>
-        <p:nvSpPr>
-          <p:cNvPr id="7" name="TextBox 6"/>
+              <a:t>AI秘書・スキル・自分専用のAIチーム</a:t>
+            </a:r>
+          </a:p>
+        </p:txBody>
+      </p:sp>
+      <p:sp>
+        <p:nvSpPr>
+          <p:cNvPr id="6" name="TextBox 5"/>
           <p:cNvSpPr txBox="1"/>
           <p:nvPr/>
         </p:nvSpPr>
         <p:spPr>
           <a:xfrm>
-            <a:off x="822960" y="1783080"/>
-            <a:ext cx="10515600" cy="822960"/>
+            <a:off x="822960" y="4206240"/>
+            <a:ext cx="10058400" cy="1371600"/>
           </a:xfrm>
           <a:prstGeom prst="rect">
             <a:avLst/>
@@ -5540,189 +5870,14 @@
               </a:spcAft>
             </a:pPr>
             <a:r>
-              <a:rPr sz="2000" b="1">
-                <a:solidFill>
-                  <a:srgbClr val="0E1B2E"/>
-                </a:solidFill>
-                <a:latin typeface="Yu Gothic"/>
-                <a:ea typeface="Yu Gothic"/>
-              </a:rPr>
-              <a:t>便利なほど、人間の確認力が大切</a:t>
-            </a:r>
-          </a:p>
-        </p:txBody>
-      </p:sp>
-      <p:sp>
-        <p:nvSpPr>
-          <p:cNvPr id="8" name="TextBox 7"/>
-          <p:cNvSpPr txBox="1"/>
-          <p:nvPr/>
-        </p:nvSpPr>
-        <p:spPr>
-          <a:xfrm>
-            <a:off x="1005840" y="2834640"/>
-            <a:ext cx="10058400" cy="3291840"/>
-          </a:xfrm>
-          <a:prstGeom prst="rect">
-            <a:avLst/>
-          </a:prstGeom>
-          <a:noFill/>
-        </p:spPr>
-        <p:txBody>
-          <a:bodyPr wrap="square" anchor="t" lIns="0" rIns="0" tIns="0" bIns="0">
-            <a:spAutoFit/>
-          </a:bodyPr>
-          <a:lstStyle/>
-          <a:p>
-            <a:pPr algn="l">
-              <a:spcAft>
-                <a:spcPts val="1000"/>
-              </a:spcAft>
-            </a:pPr>
-            <a:r>
-              <a:rPr sz="1600" b="0">
-                <a:solidFill>
-                  <a:srgbClr val="222A35"/>
-                </a:solidFill>
-                <a:latin typeface="Yu Gothic"/>
-                <a:ea typeface="Yu Gothic"/>
-              </a:rPr>
-              <a:t>●  個人情報・機密情報をそのまま入れない</a:t>
-            </a:r>
-          </a:p>
-          <a:p>
-            <a:pPr algn="l">
-              <a:spcAft>
-                <a:spcPts val="1000"/>
-              </a:spcAft>
-            </a:pPr>
-            <a:r>
-              <a:rPr sz="1600" b="0">
-                <a:solidFill>
-                  <a:srgbClr val="222A35"/>
-                </a:solidFill>
-                <a:latin typeface="Yu Gothic"/>
-                <a:ea typeface="Yu Gothic"/>
-              </a:rPr>
-              <a:t>●  日付・会場・金額・登壇者名は必ず確認</a:t>
-            </a:r>
-          </a:p>
-          <a:p>
-            <a:pPr algn="l">
-              <a:spcAft>
-                <a:spcPts val="1000"/>
-              </a:spcAft>
-            </a:pPr>
-            <a:r>
-              <a:rPr sz="1600" b="0">
-                <a:solidFill>
-                  <a:srgbClr val="222A35"/>
-                </a:solidFill>
-                <a:latin typeface="Yu Gothic"/>
-                <a:ea typeface="Yu Gothic"/>
-              </a:rPr>
-              <a:t>●  AIの文章は最後に人が確認する</a:t>
-            </a:r>
-          </a:p>
-          <a:p>
-            <a:pPr algn="l">
-              <a:spcAft>
-                <a:spcPts val="1000"/>
-              </a:spcAft>
-            </a:pPr>
-            <a:r>
-              <a:rPr sz="1600" b="0">
-                <a:solidFill>
-                  <a:srgbClr val="222A35"/>
-                </a:solidFill>
-                <a:latin typeface="Yu Gothic"/>
-                <a:ea typeface="Yu Gothic"/>
-              </a:rPr>
-              <a:t>●  AIは補佐役。最終責任者ではない</a:t>
-            </a:r>
-          </a:p>
-        </p:txBody>
-      </p:sp>
-      <p:sp>
-        <p:nvSpPr>
-          <p:cNvPr id="9" name="Rectangle 8"/>
-          <p:cNvSpPr/>
-          <p:nvPr/>
-        </p:nvSpPr>
-        <p:spPr>
-          <a:xfrm>
-            <a:off x="0" y="6565392"/>
-            <a:ext cx="12191695" cy="292608"/>
-          </a:xfrm>
-          <a:prstGeom prst="rect">
-            <a:avLst/>
-          </a:prstGeom>
-          <a:solidFill>
-            <a:srgbClr val="0E1B2E"/>
-          </a:solidFill>
-          <a:ln>
-            <a:noFill/>
-          </a:ln>
-          <a:effectLst/>
-        </p:spPr>
-        <p:style>
-          <a:lnRef idx="1">
-            <a:schemeClr val="accent1"/>
-          </a:lnRef>
-          <a:fillRef idx="3">
-            <a:schemeClr val="accent1"/>
-          </a:fillRef>
-          <a:effectRef idx="2">
-            <a:schemeClr val="accent1"/>
-          </a:effectRef>
-          <a:fontRef idx="minor">
-            <a:schemeClr val="lt1"/>
-          </a:fontRef>
-        </p:style>
-        <p:txBody>
-          <a:bodyPr rtlCol="0" anchor="ctr"/>
-          <a:lstStyle/>
-          <a:p>
-            <a:pPr algn="ctr"/>
-          </a:p>
-        </p:txBody>
-      </p:sp>
-      <p:sp>
-        <p:nvSpPr>
-          <p:cNvPr id="10" name="TextBox 9"/>
-          <p:cNvSpPr txBox="1"/>
-          <p:nvPr/>
-        </p:nvSpPr>
-        <p:spPr>
-          <a:xfrm>
-            <a:off x="822960" y="6583680"/>
-            <a:ext cx="10515600" cy="256032"/>
-          </a:xfrm>
-          <a:prstGeom prst="rect">
-            <a:avLst/>
-          </a:prstGeom>
-          <a:noFill/>
-        </p:spPr>
-        <p:txBody>
-          <a:bodyPr wrap="square" anchor="t" lIns="0" rIns="0" tIns="0" bIns="0">
-            <a:spAutoFit/>
-          </a:bodyPr>
-          <a:lstStyle/>
-          <a:p>
-            <a:pPr algn="l">
-              <a:spcAft>
-                <a:spcPts val="0"/>
-              </a:spcAft>
-            </a:pPr>
-            <a:r>
-              <a:rPr sz="1000" b="0">
-                <a:solidFill>
-                  <a:srgbClr val="9FADBD"/>
-                </a:solidFill>
-                <a:latin typeface="Yu Gothic"/>
-                <a:ea typeface="Yu Gothic"/>
-              </a:rPr>
-              <a:t>名古屋JC SNS戦略部会 ｜ AIは、使った人から変わっていく</a:t>
+              <a:rPr sz="1800" b="0">
+                <a:solidFill>
+                  <a:srgbClr val="CDD5DF"/>
+                </a:solidFill>
+                <a:latin typeface="Yu Gothic"/>
+                <a:ea typeface="Yu Gothic"/>
+              </a:rPr>
+              <a:t>日々の業務・JC活動全体にAIを使う（Claude Code）</a:t>
             </a:r>
           </a:p>
         </p:txBody>
@@ -5912,7 +6067,7 @@
                 <a:latin typeface="Yu Gothic"/>
                 <a:ea typeface="Yu Gothic"/>
               </a:rPr>
-              <a:t>17 ｜ 行動</a:t>
+              <a:t>17 ｜ 資産化</a:t>
             </a:r>
           </a:p>
         </p:txBody>
@@ -5952,7 +6107,7 @@
                 <a:latin typeface="Yu Gothic"/>
                 <a:ea typeface="Yu Gothic"/>
               </a:rPr>
-              <a:t>行動宣言</a:t>
+              <a:t>プロンプトは組織の資産になる</a:t>
             </a:r>
           </a:p>
         </p:txBody>
@@ -5992,7 +6147,7 @@
                 <a:latin typeface="Yu Gothic"/>
                 <a:ea typeface="Yu Gothic"/>
               </a:rPr>
-              <a:t>今日または明日、何を実行するか</a:t>
+              <a:t>Google Driveで共有する</a:t>
             </a:r>
           </a:p>
         </p:txBody>
@@ -6005,8 +6160,8 @@
         </p:nvSpPr>
         <p:spPr>
           <a:xfrm>
-            <a:off x="1005840" y="2834640"/>
-            <a:ext cx="10058400" cy="3291840"/>
+            <a:off x="1005840" y="2697480"/>
+            <a:ext cx="10058400" cy="3246120"/>
           </a:xfrm>
           <a:prstGeom prst="rect">
             <a:avLst/>
@@ -6021,7 +6176,7 @@
           <a:p>
             <a:pPr algn="l">
               <a:spcAft>
-                <a:spcPts val="1000"/>
+                <a:spcPts val="900"/>
               </a:spcAft>
             </a:pPr>
             <a:r>
@@ -6032,13 +6187,13 @@
                 <a:latin typeface="Yu Gothic"/>
                 <a:ea typeface="Yu Gothic"/>
               </a:rPr>
-              <a:t>●  今日・明日、実行することを一つ決める</a:t>
-            </a:r>
-          </a:p>
-          <a:p>
-            <a:pPr algn="l">
-              <a:spcAft>
-                <a:spcPts val="1000"/>
+              <a:t>●  一回使って終わりにしない</a:t>
+            </a:r>
+          </a:p>
+          <a:p>
+            <a:pPr algn="l">
+              <a:spcAft>
+                <a:spcPts val="900"/>
               </a:spcAft>
             </a:pPr>
             <a:r>
@@ -6049,13 +6204,13 @@
                 <a:latin typeface="Yu Gothic"/>
                 <a:ea typeface="Yu Gothic"/>
               </a:rPr>
-              <a:t>●  自分の委員会や会社でどう使うか</a:t>
-            </a:r>
-          </a:p>
-          <a:p>
-            <a:pPr algn="l">
-              <a:spcAft>
-                <a:spcPts val="1000"/>
+              <a:t>●  よく使うものは“型”にする</a:t>
+            </a:r>
+          </a:p>
+          <a:p>
+            <a:pPr algn="l">
+              <a:spcAft>
+                <a:spcPts val="900"/>
               </a:spcAft>
             </a:pPr>
             <a:r>
@@ -6066,7 +6221,7 @@
                 <a:latin typeface="Yu Gothic"/>
                 <a:ea typeface="Yu Gothic"/>
               </a:rPr>
-              <a:t>●  近くの人と共有する</a:t>
+              <a:t>●  型にすると、個人のスキルが組織の資産に</a:t>
             </a:r>
           </a:p>
         </p:txBody>
@@ -6340,7 +6495,7 @@
                 <a:latin typeface="Yu Gothic"/>
                 <a:ea typeface="Yu Gothic"/>
               </a:rPr>
-              <a:t>18 ｜ 伝える</a:t>
+              <a:t>18 ｜ 注意点</a:t>
             </a:r>
           </a:p>
         </p:txBody>
@@ -6380,7 +6535,7 @@
                 <a:latin typeface="Yu Gothic"/>
                 <a:ea typeface="Yu Gothic"/>
               </a:rPr>
-              <a:t>誰に伝えるか</a:t>
+              <a:t>AI活用の注意点</a:t>
             </a:r>
           </a:p>
         </p:txBody>
@@ -6420,7 +6575,7 @@
                 <a:latin typeface="Yu Gothic"/>
                 <a:ea typeface="Yu Gothic"/>
               </a:rPr>
-              <a:t>教えることが一番の学びになる</a:t>
+              <a:t>便利なほど、人間の確認力が大切</a:t>
             </a:r>
           </a:p>
         </p:txBody>
@@ -6433,8 +6588,8 @@
         </p:nvSpPr>
         <p:spPr>
           <a:xfrm>
-            <a:off x="1005840" y="2834640"/>
-            <a:ext cx="10058400" cy="3291840"/>
+            <a:off x="1005840" y="2697480"/>
+            <a:ext cx="10058400" cy="3246120"/>
           </a:xfrm>
           <a:prstGeom prst="rect">
             <a:avLst/>
@@ -6449,7 +6604,7 @@
           <a:p>
             <a:pPr algn="l">
               <a:spcAft>
-                <a:spcPts val="1000"/>
+                <a:spcPts val="900"/>
               </a:spcAft>
             </a:pPr>
             <a:r>
@@ -6460,13 +6615,13 @@
                 <a:latin typeface="Yu Gothic"/>
                 <a:ea typeface="Yu Gothic"/>
               </a:rPr>
-              <a:t>●  委員会メンバー・会社のスタッフ・家族でもいい</a:t>
-            </a:r>
-          </a:p>
-          <a:p>
-            <a:pPr algn="l">
-              <a:spcAft>
-                <a:spcPts val="1000"/>
+              <a:t>●  個人情報・機密情報をそのまま入れない</a:t>
+            </a:r>
+          </a:p>
+          <a:p>
+            <a:pPr algn="l">
+              <a:spcAft>
+                <a:spcPts val="900"/>
               </a:spcAft>
             </a:pPr>
             <a:r>
@@ -6477,13 +6632,13 @@
                 <a:latin typeface="Yu Gothic"/>
                 <a:ea typeface="Yu Gothic"/>
               </a:rPr>
-              <a:t>●  一人で使うより、共有した方が組織の力になる</a:t>
-            </a:r>
-          </a:p>
-          <a:p>
-            <a:pPr algn="l">
-              <a:spcAft>
-                <a:spcPts val="1000"/>
+              <a:t>●  日付・会場・金額・登壇者名は必ず確認</a:t>
+            </a:r>
+          </a:p>
+          <a:p>
+            <a:pPr algn="l">
+              <a:spcAft>
+                <a:spcPts val="900"/>
               </a:spcAft>
             </a:pPr>
             <a:r>
@@ -6494,7 +6649,24 @@
                 <a:latin typeface="Yu Gothic"/>
                 <a:ea typeface="Yu Gothic"/>
               </a:rPr>
-              <a:t>●  教えることで自分の理解が深まる</a:t>
+              <a:t>●  AIの文章は最後に人が確認する</a:t>
+            </a:r>
+          </a:p>
+          <a:p>
+            <a:pPr algn="l">
+              <a:spcAft>
+                <a:spcPts val="900"/>
+              </a:spcAft>
+            </a:pPr>
+            <a:r>
+              <a:rPr sz="1600" b="0">
+                <a:solidFill>
+                  <a:srgbClr val="222A35"/>
+                </a:solidFill>
+                <a:latin typeface="Yu Gothic"/>
+                <a:ea typeface="Yu Gothic"/>
+              </a:rPr>
+              <a:t>●  AIは補佐役。最終責任者ではない</a:t>
             </a:r>
           </a:p>
         </p:txBody>
@@ -6768,7 +6940,7 @@
                 <a:latin typeface="Yu Gothic"/>
                 <a:ea typeface="Yu Gothic"/>
               </a:rPr>
-              <a:t>19 ｜ 案内</a:t>
+              <a:t>19 ｜ 行動</a:t>
             </a:r>
           </a:p>
         </p:txBody>
@@ -6808,7 +6980,7 @@
                 <a:latin typeface="Yu Gothic"/>
                 <a:ea typeface="Yu Gothic"/>
               </a:rPr>
-              <a:t>アンケート案内</a:t>
+              <a:t>行動宣言</a:t>
             </a:r>
           </a:p>
         </p:txBody>
@@ -6848,7 +7020,7 @@
                 <a:latin typeface="Yu Gothic"/>
                 <a:ea typeface="Yu Gothic"/>
               </a:rPr>
-              <a:t>回答者に共有資料を送付</a:t>
+              <a:t>今日または明日、何を実行するか</a:t>
             </a:r>
           </a:p>
         </p:txBody>
@@ -6861,8 +7033,8 @@
         </p:nvSpPr>
         <p:spPr>
           <a:xfrm>
-            <a:off x="1005840" y="2834640"/>
-            <a:ext cx="10058400" cy="3291840"/>
+            <a:off x="1005840" y="2697480"/>
+            <a:ext cx="10058400" cy="3246120"/>
           </a:xfrm>
           <a:prstGeom prst="rect">
             <a:avLst/>
@@ -6877,7 +7049,7 @@
           <a:p>
             <a:pPr algn="l">
               <a:spcAft>
-                <a:spcPts val="1000"/>
+                <a:spcPts val="900"/>
               </a:spcAft>
             </a:pPr>
             <a:r>
@@ -6888,13 +7060,13 @@
                 <a:latin typeface="Yu Gothic"/>
                 <a:ea typeface="Yu Gothic"/>
               </a:rPr>
-              <a:t>●  本日のスライド／実演で使ったプロンプト集</a:t>
-            </a:r>
-          </a:p>
-          <a:p>
-            <a:pPr algn="l">
-              <a:spcAft>
-                <a:spcPts val="1000"/>
+              <a:t>●  実行することを一つ決める</a:t>
+            </a:r>
+          </a:p>
+          <a:p>
+            <a:pPr algn="l">
+              <a:spcAft>
+                <a:spcPts val="900"/>
               </a:spcAft>
             </a:pPr>
             <a:r>
@@ -6905,13 +7077,13 @@
                 <a:latin typeface="Yu Gothic"/>
                 <a:ea typeface="Yu Gothic"/>
               </a:rPr>
-              <a:t>●  AI秘書の概要／おすすめAIツール一覧</a:t>
-            </a:r>
-          </a:p>
-          <a:p>
-            <a:pPr algn="l">
-              <a:spcAft>
-                <a:spcPts val="1000"/>
+              <a:t>●  自分の委員会や会社でどう使うか</a:t>
+            </a:r>
+          </a:p>
+          <a:p>
+            <a:pPr algn="l">
+              <a:spcAft>
+                <a:spcPts val="900"/>
               </a:spcAft>
             </a:pPr>
             <a:r>
@@ -6922,7 +7094,7 @@
                 <a:latin typeface="Yu Gothic"/>
                 <a:ea typeface="Yu Gothic"/>
               </a:rPr>
-              <a:t>●  Google Driveマニュアル／アクションリスト</a:t>
+              <a:t>●  近くの人と共有する</a:t>
             </a:r>
           </a:p>
         </p:txBody>
@@ -7196,7 +7368,7 @@
                 <a:latin typeface="Yu Gothic"/>
                 <a:ea typeface="Yu Gothic"/>
               </a:rPr>
-              <a:t>02 ｜ 本日のゴール</a:t>
+              <a:t>02 ｜ 自己紹介</a:t>
             </a:r>
           </a:p>
         </p:txBody>
@@ -7236,7 +7408,7 @@
                 <a:latin typeface="Yu Gothic"/>
                 <a:ea typeface="Yu Gothic"/>
               </a:rPr>
-              <a:t>今日または明日、AIを一つ実践する</a:t>
+              <a:t>自己紹介（さらっと）</a:t>
             </a:r>
           </a:p>
         </p:txBody>
@@ -7249,8 +7421,8 @@
         </p:nvSpPr>
         <p:spPr>
           <a:xfrm>
-            <a:off x="1005840" y="2834640"/>
-            <a:ext cx="10058400" cy="3291840"/>
+            <a:off x="822960" y="1783080"/>
+            <a:ext cx="10515600" cy="822960"/>
           </a:xfrm>
           <a:prstGeom prst="rect">
             <a:avLst/>
@@ -7265,59 +7437,167 @@
           <a:p>
             <a:pPr algn="l">
               <a:spcAft>
-                <a:spcPts val="1000"/>
-              </a:spcAft>
-            </a:pPr>
-            <a:r>
-              <a:rPr sz="1600" b="0">
+                <a:spcPts val="0"/>
+              </a:spcAft>
+            </a:pPr>
+            <a:r>
+              <a:rPr sz="2000" b="1">
+                <a:solidFill>
+                  <a:srgbClr val="0E1B2E"/>
+                </a:solidFill>
+                <a:latin typeface="Yu Gothic"/>
+                <a:ea typeface="Yu Gothic"/>
+              </a:rPr>
+              <a:t>名古屋JCでの歩み（2016〜）</a:t>
+            </a:r>
+          </a:p>
+        </p:txBody>
+      </p:sp>
+      <p:sp>
+        <p:nvSpPr>
+          <p:cNvPr id="8" name="TextBox 7"/>
+          <p:cNvSpPr txBox="1"/>
+          <p:nvPr/>
+        </p:nvSpPr>
+        <p:spPr>
+          <a:xfrm>
+            <a:off x="1005840" y="2697480"/>
+            <a:ext cx="10058400" cy="3246120"/>
+          </a:xfrm>
+          <a:prstGeom prst="rect">
+            <a:avLst/>
+          </a:prstGeom>
+          <a:noFill/>
+        </p:spPr>
+        <p:txBody>
+          <a:bodyPr wrap="square" anchor="t" lIns="0" rIns="0" tIns="0" bIns="0">
+            <a:spAutoFit/>
+          </a:bodyPr>
+          <a:lstStyle/>
+          <a:p>
+            <a:pPr algn="l">
+              <a:spcAft>
+                <a:spcPts val="900"/>
+              </a:spcAft>
+            </a:pPr>
+            <a:r>
+              <a:rPr sz="1500" b="0">
                 <a:solidFill>
                   <a:srgbClr val="222A35"/>
                 </a:solidFill>
                 <a:latin typeface="Yu Gothic"/>
                 <a:ea typeface="Yu Gothic"/>
               </a:rPr>
-              <a:t>●  今日のゴールは、AIに詳しくなることではない</a:t>
-            </a:r>
-          </a:p>
-          <a:p>
-            <a:pPr algn="l">
-              <a:spcAft>
-                <a:spcPts val="1000"/>
-              </a:spcAft>
-            </a:pPr>
-            <a:r>
-              <a:rPr sz="1600" b="0">
+              <a:t>●  2016　名古屋JC 入会</a:t>
+            </a:r>
+          </a:p>
+          <a:p>
+            <a:pPr algn="l">
+              <a:spcAft>
+                <a:spcPts val="900"/>
+              </a:spcAft>
+            </a:pPr>
+            <a:r>
+              <a:rPr sz="1500" b="0">
                 <a:solidFill>
                   <a:srgbClr val="222A35"/>
                 </a:solidFill>
                 <a:latin typeface="Yu Gothic"/>
                 <a:ea typeface="Yu Gothic"/>
               </a:rPr>
-              <a:t>●  明日から一つ、実際に使えるようになること</a:t>
-            </a:r>
-          </a:p>
-          <a:p>
-            <a:pPr algn="l">
-              <a:spcAft>
-                <a:spcPts val="1000"/>
-              </a:spcAft>
-            </a:pPr>
-            <a:r>
-              <a:rPr sz="1600" b="0">
+              <a:t>●  2021　塾長／選挙</a:t>
+            </a:r>
+          </a:p>
+          <a:p>
+            <a:pPr algn="l">
+              <a:spcAft>
+                <a:spcPts val="900"/>
+              </a:spcAft>
+            </a:pPr>
+            <a:r>
+              <a:rPr sz="1500" b="0">
                 <a:solidFill>
                   <a:srgbClr val="222A35"/>
                 </a:solidFill>
                 <a:latin typeface="Yu Gothic"/>
                 <a:ea typeface="Yu Gothic"/>
               </a:rPr>
-              <a:t>●  知っている人ではなく、使った人から変わる</a:t>
-            </a:r>
-          </a:p>
-        </p:txBody>
-      </p:sp>
-      <p:sp>
-        <p:nvSpPr>
-          <p:cNvPr id="8" name="Rectangle 7"/>
+              <a:t>●  2022　SDGs実践委員会 委員長</a:t>
+            </a:r>
+          </a:p>
+          <a:p>
+            <a:pPr algn="l">
+              <a:spcAft>
+                <a:spcPts val="900"/>
+              </a:spcAft>
+            </a:pPr>
+            <a:r>
+              <a:rPr sz="1500" b="0">
+                <a:solidFill>
+                  <a:srgbClr val="222A35"/>
+                </a:solidFill>
+                <a:latin typeface="Yu Gothic"/>
+                <a:ea typeface="Yu Gothic"/>
+              </a:rPr>
+              <a:t>●  2023　名古屋の魅力発信委員会 アドバイザー</a:t>
+            </a:r>
+          </a:p>
+          <a:p>
+            <a:pPr algn="l">
+              <a:spcAft>
+                <a:spcPts val="900"/>
+              </a:spcAft>
+            </a:pPr>
+            <a:r>
+              <a:rPr sz="1500" b="0">
+                <a:solidFill>
+                  <a:srgbClr val="222A35"/>
+                </a:solidFill>
+                <a:latin typeface="Yu Gothic"/>
+                <a:ea typeface="Yu Gothic"/>
+              </a:rPr>
+              <a:t>●  2024　常任理事（渉外室長）</a:t>
+            </a:r>
+          </a:p>
+          <a:p>
+            <a:pPr algn="l">
+              <a:spcAft>
+                <a:spcPts val="900"/>
+              </a:spcAft>
+            </a:pPr>
+            <a:r>
+              <a:rPr sz="1500" b="0">
+                <a:solidFill>
+                  <a:srgbClr val="222A35"/>
+                </a:solidFill>
+                <a:latin typeface="Yu Gothic"/>
+                <a:ea typeface="Yu Gothic"/>
+              </a:rPr>
+              <a:t>●  2025　国際都市交流推進特別委員会 アドバイザー／わんぱく相撲 議長補佐</a:t>
+            </a:r>
+          </a:p>
+          <a:p>
+            <a:pPr algn="l">
+              <a:spcAft>
+                <a:spcPts val="900"/>
+              </a:spcAft>
+            </a:pPr>
+            <a:r>
+              <a:rPr sz="1500" b="0">
+                <a:solidFill>
+                  <a:srgbClr val="222A35"/>
+                </a:solidFill>
+                <a:latin typeface="Yu Gothic"/>
+                <a:ea typeface="Yu Gothic"/>
+              </a:rPr>
+              <a:t>●  2026　広報アドバイザー／グローバルアライアンス構築委員会／SNS15アカウント運用</a:t>
+            </a:r>
+          </a:p>
+        </p:txBody>
+      </p:sp>
+      <p:sp>
+        <p:nvSpPr>
+          <p:cNvPr id="9" name="Rectangle 8"/>
           <p:cNvSpPr/>
           <p:nvPr/>
         </p:nvSpPr>
@@ -7361,7 +7641,7 @@
       </p:sp>
       <p:sp>
         <p:nvSpPr>
-          <p:cNvPr id="9" name="TextBox 8"/>
+          <p:cNvPr id="10" name="TextBox 9"/>
           <p:cNvSpPr txBox="1"/>
           <p:nvPr/>
         </p:nvSpPr>
@@ -7432,6 +7712,50 @@
             <a:avLst/>
           </a:prstGeom>
           <a:solidFill>
+            <a:srgbClr val="F7F5EF"/>
+          </a:solidFill>
+          <a:ln>
+            <a:noFill/>
+          </a:ln>
+          <a:effectLst/>
+        </p:spPr>
+        <p:style>
+          <a:lnRef idx="1">
+            <a:schemeClr val="accent1"/>
+          </a:lnRef>
+          <a:fillRef idx="3">
+            <a:schemeClr val="accent1"/>
+          </a:fillRef>
+          <a:effectRef idx="2">
+            <a:schemeClr val="accent1"/>
+          </a:effectRef>
+          <a:fontRef idx="minor">
+            <a:schemeClr val="lt1"/>
+          </a:fontRef>
+        </p:style>
+        <p:txBody>
+          <a:bodyPr rtlCol="0" anchor="ctr"/>
+          <a:lstStyle/>
+          <a:p>
+            <a:pPr algn="ctr"/>
+          </a:p>
+        </p:txBody>
+      </p:sp>
+      <p:sp>
+        <p:nvSpPr>
+          <p:cNvPr id="3" name="Rectangle 2"/>
+          <p:cNvSpPr/>
+          <p:nvPr/>
+        </p:nvSpPr>
+        <p:spPr>
+          <a:xfrm>
+            <a:off x="0" y="0"/>
+            <a:ext cx="12191695" cy="1371600"/>
+          </a:xfrm>
+          <a:prstGeom prst="rect">
+            <a:avLst/>
+          </a:prstGeom>
+          <a:solidFill>
             <a:srgbClr val="0E1B2E"/>
           </a:solidFill>
           <a:ln>
@@ -7463,14 +7787,14 @@
       </p:sp>
       <p:sp>
         <p:nvSpPr>
-          <p:cNvPr id="3" name="Rectangle 2"/>
+          <p:cNvPr id="4" name="Rectangle 3"/>
           <p:cNvSpPr/>
           <p:nvPr/>
         </p:nvSpPr>
         <p:spPr>
           <a:xfrm>
-            <a:off x="0" y="6693408"/>
-            <a:ext cx="12191695" cy="164592"/>
+            <a:off x="0" y="1371600"/>
+            <a:ext cx="12191695" cy="54864"/>
           </a:xfrm>
           <a:prstGeom prst="rect">
             <a:avLst/>
@@ -7507,14 +7831,354 @@
       </p:sp>
       <p:sp>
         <p:nvSpPr>
-          <p:cNvPr id="4" name="Rectangle 3"/>
+          <p:cNvPr id="5" name="TextBox 4"/>
+          <p:cNvSpPr txBox="1"/>
+          <p:nvPr/>
+        </p:nvSpPr>
+        <p:spPr>
+          <a:xfrm>
+            <a:off x="822960" y="310896"/>
+            <a:ext cx="10515600" cy="365760"/>
+          </a:xfrm>
+          <a:prstGeom prst="rect">
+            <a:avLst/>
+          </a:prstGeom>
+          <a:noFill/>
+        </p:spPr>
+        <p:txBody>
+          <a:bodyPr wrap="square" anchor="t" lIns="0" rIns="0" tIns="0" bIns="0">
+            <a:spAutoFit/>
+          </a:bodyPr>
+          <a:lstStyle/>
+          <a:p>
+            <a:pPr algn="l">
+              <a:spcAft>
+                <a:spcPts val="0"/>
+              </a:spcAft>
+            </a:pPr>
+            <a:r>
+              <a:rPr sz="1300" b="1">
+                <a:solidFill>
+                  <a:srgbClr val="E3C373"/>
+                </a:solidFill>
+                <a:latin typeface="Yu Gothic"/>
+                <a:ea typeface="Yu Gothic"/>
+              </a:rPr>
+              <a:t>20 ｜ 伝える</a:t>
+            </a:r>
+          </a:p>
+        </p:txBody>
+      </p:sp>
+      <p:sp>
+        <p:nvSpPr>
+          <p:cNvPr id="6" name="TextBox 5"/>
+          <p:cNvSpPr txBox="1"/>
+          <p:nvPr/>
+        </p:nvSpPr>
+        <p:spPr>
+          <a:xfrm>
+            <a:off x="822960" y="676656"/>
+            <a:ext cx="10515600" cy="640080"/>
+          </a:xfrm>
+          <a:prstGeom prst="rect">
+            <a:avLst/>
+          </a:prstGeom>
+          <a:noFill/>
+        </p:spPr>
+        <p:txBody>
+          <a:bodyPr wrap="square" anchor="t" lIns="0" rIns="0" tIns="0" bIns="0">
+            <a:spAutoFit/>
+          </a:bodyPr>
+          <a:lstStyle/>
+          <a:p>
+            <a:pPr algn="l">
+              <a:spcAft>
+                <a:spcPts val="0"/>
+              </a:spcAft>
+            </a:pPr>
+            <a:r>
+              <a:rPr sz="2600" b="1">
+                <a:solidFill>
+                  <a:srgbClr val="FFFFFF"/>
+                </a:solidFill>
+                <a:latin typeface="Yu Gothic"/>
+                <a:ea typeface="Yu Gothic"/>
+              </a:rPr>
+              <a:t>誰に伝えるか</a:t>
+            </a:r>
+          </a:p>
+        </p:txBody>
+      </p:sp>
+      <p:sp>
+        <p:nvSpPr>
+          <p:cNvPr id="7" name="TextBox 6"/>
+          <p:cNvSpPr txBox="1"/>
+          <p:nvPr/>
+        </p:nvSpPr>
+        <p:spPr>
+          <a:xfrm>
+            <a:off x="822960" y="1783080"/>
+            <a:ext cx="10515600" cy="822960"/>
+          </a:xfrm>
+          <a:prstGeom prst="rect">
+            <a:avLst/>
+          </a:prstGeom>
+          <a:noFill/>
+        </p:spPr>
+        <p:txBody>
+          <a:bodyPr wrap="square" anchor="t" lIns="0" rIns="0" tIns="0" bIns="0">
+            <a:spAutoFit/>
+          </a:bodyPr>
+          <a:lstStyle/>
+          <a:p>
+            <a:pPr algn="l">
+              <a:spcAft>
+                <a:spcPts val="0"/>
+              </a:spcAft>
+            </a:pPr>
+            <a:r>
+              <a:rPr sz="2000" b="1">
+                <a:solidFill>
+                  <a:srgbClr val="0E1B2E"/>
+                </a:solidFill>
+                <a:latin typeface="Yu Gothic"/>
+                <a:ea typeface="Yu Gothic"/>
+              </a:rPr>
+              <a:t>教えることが一番の学びになる</a:t>
+            </a:r>
+          </a:p>
+        </p:txBody>
+      </p:sp>
+      <p:sp>
+        <p:nvSpPr>
+          <p:cNvPr id="8" name="TextBox 7"/>
+          <p:cNvSpPr txBox="1"/>
+          <p:nvPr/>
+        </p:nvSpPr>
+        <p:spPr>
+          <a:xfrm>
+            <a:off x="1005840" y="2697480"/>
+            <a:ext cx="10058400" cy="3246120"/>
+          </a:xfrm>
+          <a:prstGeom prst="rect">
+            <a:avLst/>
+          </a:prstGeom>
+          <a:noFill/>
+        </p:spPr>
+        <p:txBody>
+          <a:bodyPr wrap="square" anchor="t" lIns="0" rIns="0" tIns="0" bIns="0">
+            <a:spAutoFit/>
+          </a:bodyPr>
+          <a:lstStyle/>
+          <a:p>
+            <a:pPr algn="l">
+              <a:spcAft>
+                <a:spcPts val="900"/>
+              </a:spcAft>
+            </a:pPr>
+            <a:r>
+              <a:rPr sz="1600" b="0">
+                <a:solidFill>
+                  <a:srgbClr val="222A35"/>
+                </a:solidFill>
+                <a:latin typeface="Yu Gothic"/>
+                <a:ea typeface="Yu Gothic"/>
+              </a:rPr>
+              <a:t>●  委員会・会社・家族の誰でもいい</a:t>
+            </a:r>
+          </a:p>
+          <a:p>
+            <a:pPr algn="l">
+              <a:spcAft>
+                <a:spcPts val="900"/>
+              </a:spcAft>
+            </a:pPr>
+            <a:r>
+              <a:rPr sz="1600" b="0">
+                <a:solidFill>
+                  <a:srgbClr val="222A35"/>
+                </a:solidFill>
+                <a:latin typeface="Yu Gothic"/>
+                <a:ea typeface="Yu Gothic"/>
+              </a:rPr>
+              <a:t>●  一人で使うより、共有した方が組織の力に</a:t>
+            </a:r>
+          </a:p>
+          <a:p>
+            <a:pPr algn="l">
+              <a:spcAft>
+                <a:spcPts val="900"/>
+              </a:spcAft>
+            </a:pPr>
+            <a:r>
+              <a:rPr sz="1600" b="0">
+                <a:solidFill>
+                  <a:srgbClr val="222A35"/>
+                </a:solidFill>
+                <a:latin typeface="Yu Gothic"/>
+                <a:ea typeface="Yu Gothic"/>
+              </a:rPr>
+              <a:t>●  教えることで自分の理解が深まる</a:t>
+            </a:r>
+          </a:p>
+        </p:txBody>
+      </p:sp>
+      <p:sp>
+        <p:nvSpPr>
+          <p:cNvPr id="9" name="Rectangle 8"/>
           <p:cNvSpPr/>
           <p:nvPr/>
         </p:nvSpPr>
         <p:spPr>
           <a:xfrm>
-            <a:off x="822960" y="2331720"/>
-            <a:ext cx="1463040" cy="82296"/>
+            <a:off x="0" y="6565392"/>
+            <a:ext cx="12191695" cy="292608"/>
+          </a:xfrm>
+          <a:prstGeom prst="rect">
+            <a:avLst/>
+          </a:prstGeom>
+          <a:solidFill>
+            <a:srgbClr val="0E1B2E"/>
+          </a:solidFill>
+          <a:ln>
+            <a:noFill/>
+          </a:ln>
+          <a:effectLst/>
+        </p:spPr>
+        <p:style>
+          <a:lnRef idx="1">
+            <a:schemeClr val="accent1"/>
+          </a:lnRef>
+          <a:fillRef idx="3">
+            <a:schemeClr val="accent1"/>
+          </a:fillRef>
+          <a:effectRef idx="2">
+            <a:schemeClr val="accent1"/>
+          </a:effectRef>
+          <a:fontRef idx="minor">
+            <a:schemeClr val="lt1"/>
+          </a:fontRef>
+        </p:style>
+        <p:txBody>
+          <a:bodyPr rtlCol="0" anchor="ctr"/>
+          <a:lstStyle/>
+          <a:p>
+            <a:pPr algn="ctr"/>
+          </a:p>
+        </p:txBody>
+      </p:sp>
+      <p:sp>
+        <p:nvSpPr>
+          <p:cNvPr id="10" name="TextBox 9"/>
+          <p:cNvSpPr txBox="1"/>
+          <p:nvPr/>
+        </p:nvSpPr>
+        <p:spPr>
+          <a:xfrm>
+            <a:off x="822960" y="6583680"/>
+            <a:ext cx="10515600" cy="256032"/>
+          </a:xfrm>
+          <a:prstGeom prst="rect">
+            <a:avLst/>
+          </a:prstGeom>
+          <a:noFill/>
+        </p:spPr>
+        <p:txBody>
+          <a:bodyPr wrap="square" anchor="t" lIns="0" rIns="0" tIns="0" bIns="0">
+            <a:spAutoFit/>
+          </a:bodyPr>
+          <a:lstStyle/>
+          <a:p>
+            <a:pPr algn="l">
+              <a:spcAft>
+                <a:spcPts val="0"/>
+              </a:spcAft>
+            </a:pPr>
+            <a:r>
+              <a:rPr sz="1000" b="0">
+                <a:solidFill>
+                  <a:srgbClr val="9FADBD"/>
+                </a:solidFill>
+                <a:latin typeface="Yu Gothic"/>
+                <a:ea typeface="Yu Gothic"/>
+              </a:rPr>
+              <a:t>名古屋JC SNS戦略部会 ｜ AIは、使った人から変わっていく</a:t>
+            </a:r>
+          </a:p>
+        </p:txBody>
+      </p:sp>
+    </p:spTree>
+  </p:cSld>
+  <p:clrMapOvr>
+    <a:masterClrMapping/>
+  </p:clrMapOvr>
+</p:sld>
+</file>
+
+<file path=ppt/slides/slide21.xml><?xml version="1.0" encoding="utf-8"?>
+<p:sld xmlns:a="http://schemas.openxmlformats.org/drawingml/2006/main" xmlns:p="http://schemas.openxmlformats.org/presentationml/2006/main" xmlns:r="http://schemas.openxmlformats.org/officeDocument/2006/relationships">
+  <p:cSld>
+    <p:spTree>
+      <p:nvGrpSpPr>
+        <p:cNvPr id="1" name=""/>
+        <p:cNvGrpSpPr/>
+        <p:nvPr/>
+      </p:nvGrpSpPr>
+      <p:grpSpPr/>
+      <p:sp>
+        <p:nvSpPr>
+          <p:cNvPr id="2" name="Rectangle 1"/>
+          <p:cNvSpPr/>
+          <p:nvPr/>
+        </p:nvSpPr>
+        <p:spPr>
+          <a:xfrm>
+            <a:off x="0" y="0"/>
+            <a:ext cx="12191695" cy="6858000"/>
+          </a:xfrm>
+          <a:prstGeom prst="rect">
+            <a:avLst/>
+          </a:prstGeom>
+          <a:solidFill>
+            <a:srgbClr val="0E1B2E"/>
+          </a:solidFill>
+          <a:ln>
+            <a:noFill/>
+          </a:ln>
+          <a:effectLst/>
+        </p:spPr>
+        <p:style>
+          <a:lnRef idx="1">
+            <a:schemeClr val="accent1"/>
+          </a:lnRef>
+          <a:fillRef idx="3">
+            <a:schemeClr val="accent1"/>
+          </a:fillRef>
+          <a:effectRef idx="2">
+            <a:schemeClr val="accent1"/>
+          </a:effectRef>
+          <a:fontRef idx="minor">
+            <a:schemeClr val="lt1"/>
+          </a:fontRef>
+        </p:style>
+        <p:txBody>
+          <a:bodyPr rtlCol="0" anchor="ctr"/>
+          <a:lstStyle/>
+          <a:p>
+            <a:pPr algn="ctr"/>
+          </a:p>
+        </p:txBody>
+      </p:sp>
+      <p:sp>
+        <p:nvSpPr>
+          <p:cNvPr id="3" name="Rectangle 2"/>
+          <p:cNvSpPr/>
+          <p:nvPr/>
+        </p:nvSpPr>
+        <p:spPr>
+          <a:xfrm>
+            <a:off x="0" y="6693408"/>
+            <a:ext cx="12191695" cy="164592"/>
           </a:xfrm>
           <a:prstGeom prst="rect">
             <a:avLst/>
@@ -7551,6 +8215,50 @@
       </p:sp>
       <p:sp>
         <p:nvSpPr>
+          <p:cNvPr id="4" name="Rectangle 3"/>
+          <p:cNvSpPr/>
+          <p:nvPr/>
+        </p:nvSpPr>
+        <p:spPr>
+          <a:xfrm>
+            <a:off x="822960" y="2331720"/>
+            <a:ext cx="1463040" cy="82296"/>
+          </a:xfrm>
+          <a:prstGeom prst="rect">
+            <a:avLst/>
+          </a:prstGeom>
+          <a:solidFill>
+            <a:srgbClr val="C9A24B"/>
+          </a:solidFill>
+          <a:ln>
+            <a:noFill/>
+          </a:ln>
+          <a:effectLst/>
+        </p:spPr>
+        <p:style>
+          <a:lnRef idx="1">
+            <a:schemeClr val="accent1"/>
+          </a:lnRef>
+          <a:fillRef idx="3">
+            <a:schemeClr val="accent1"/>
+          </a:fillRef>
+          <a:effectRef idx="2">
+            <a:schemeClr val="accent1"/>
+          </a:effectRef>
+          <a:fontRef idx="minor">
+            <a:schemeClr val="lt1"/>
+          </a:fontRef>
+        </p:style>
+        <p:txBody>
+          <a:bodyPr rtlCol="0" anchor="ctr"/>
+          <a:lstStyle/>
+          <a:p>
+            <a:pPr algn="ctr"/>
+          </a:p>
+        </p:txBody>
+      </p:sp>
+      <p:sp>
+        <p:nvSpPr>
           <p:cNvPr id="5" name="TextBox 4"/>
           <p:cNvSpPr txBox="1"/>
           <p:nvPr/>
@@ -7639,7 +8347,7 @@
         <p:spPr>
           <a:xfrm>
             <a:off x="822960" y="5212080"/>
-            <a:ext cx="10515600" cy="548640"/>
+            <a:ext cx="10515600" cy="731520"/>
           </a:xfrm>
           <a:prstGeom prst="rect">
             <a:avLst/>
@@ -7895,7 +8603,7 @@
                 <a:latin typeface="Yu Gothic"/>
                 <a:ea typeface="Yu Gothic"/>
               </a:rPr>
-              <a:t>AI専門家ではなく、実践者として話す</a:t>
+              <a:t>SNS×事業の実績</a:t>
             </a:r>
           </a:p>
         </p:txBody>
@@ -7908,8 +8616,8 @@
         </p:nvSpPr>
         <p:spPr>
           <a:xfrm>
-            <a:off x="1005840" y="2834640"/>
-            <a:ext cx="10058400" cy="3291840"/>
+            <a:off x="822960" y="1783080"/>
+            <a:ext cx="10515600" cy="822960"/>
           </a:xfrm>
           <a:prstGeom prst="rect">
             <a:avLst/>
@@ -7924,7 +8632,47 @@
           <a:p>
             <a:pPr algn="l">
               <a:spcAft>
-                <a:spcPts val="1000"/>
+                <a:spcPts val="0"/>
+              </a:spcAft>
+            </a:pPr>
+            <a:r>
+              <a:rPr sz="2000" b="1">
+                <a:solidFill>
+                  <a:srgbClr val="0E1B2E"/>
+                </a:solidFill>
+                <a:latin typeface="Yu Gothic"/>
+                <a:ea typeface="Yu Gothic"/>
+              </a:rPr>
+              <a:t>SNSで“知ってもらう”が、事業の成果に</a:t>
+            </a:r>
+          </a:p>
+        </p:txBody>
+      </p:sp>
+      <p:sp>
+        <p:nvSpPr>
+          <p:cNvPr id="8" name="TextBox 7"/>
+          <p:cNvSpPr txBox="1"/>
+          <p:nvPr/>
+        </p:nvSpPr>
+        <p:spPr>
+          <a:xfrm>
+            <a:off x="1005840" y="2697480"/>
+            <a:ext cx="10058400" cy="3246120"/>
+          </a:xfrm>
+          <a:prstGeom prst="rect">
+            <a:avLst/>
+          </a:prstGeom>
+          <a:noFill/>
+        </p:spPr>
+        <p:txBody>
+          <a:bodyPr wrap="square" anchor="t" lIns="0" rIns="0" tIns="0" bIns="0">
+            <a:spAutoFit/>
+          </a:bodyPr>
+          <a:lstStyle/>
+          <a:p>
+            <a:pPr algn="l">
+              <a:spcAft>
+                <a:spcPts val="900"/>
               </a:spcAft>
             </a:pPr>
             <a:r>
@@ -7935,13 +8683,13 @@
                 <a:latin typeface="Yu Gothic"/>
                 <a:ea typeface="Yu Gothic"/>
               </a:rPr>
-              <a:t>●  JC活動・事業・SNS運用の中でAIを使い倒してきた</a:t>
-            </a:r>
-          </a:p>
-          <a:p>
-            <a:pPr algn="l">
-              <a:spcAft>
-                <a:spcPts val="1000"/>
+              <a:t>●  鰻の通販「うなぎのぼり」を運営</a:t>
+            </a:r>
+          </a:p>
+          <a:p>
+            <a:pPr algn="l">
+              <a:spcAft>
+                <a:spcPts val="900"/>
               </a:spcAft>
             </a:pPr>
             <a:r>
@@ -7952,13 +8700,13 @@
                 <a:latin typeface="Yu Gothic"/>
                 <a:ea typeface="Yu Gothic"/>
               </a:rPr>
-              <a:t>●  AI歴は本格的にはまだ半年ほど</a:t>
-            </a:r>
-          </a:p>
-          <a:p>
-            <a:pPr algn="l">
-              <a:spcAft>
-                <a:spcPts val="1000"/>
+              <a:t>●  LinkedIn → インバウンドで海外パートナー獲得</a:t>
+            </a:r>
+          </a:p>
+          <a:p>
+            <a:pPr algn="l">
+              <a:spcAft>
+                <a:spcPts val="900"/>
               </a:spcAft>
             </a:pPr>
             <a:r>
@@ -7969,14 +8717,65 @@
                 <a:latin typeface="Yu Gothic"/>
                 <a:ea typeface="Yu Gothic"/>
               </a:rPr>
-              <a:t>●  半年で、資料・SNS・タスク・情報共有が一変</a:t>
-            </a:r>
-          </a:p>
-        </p:txBody>
-      </p:sp>
-      <p:sp>
-        <p:nvSpPr>
-          <p:cNvPr id="8" name="Rectangle 7"/>
+              <a:t>●  Threads → イベント集客</a:t>
+            </a:r>
+          </a:p>
+          <a:p>
+            <a:pPr algn="l">
+              <a:spcAft>
+                <a:spcPts val="900"/>
+              </a:spcAft>
+            </a:pPr>
+            <a:r>
+              <a:rPr sz="1600" b="0">
+                <a:solidFill>
+                  <a:srgbClr val="222A35"/>
+                </a:solidFill>
+                <a:latin typeface="Yu Gothic"/>
+                <a:ea typeface="Yu Gothic"/>
+              </a:rPr>
+              <a:t>●  福祉事業 → 満床経営を実現</a:t>
+            </a:r>
+          </a:p>
+          <a:p>
+            <a:pPr algn="l">
+              <a:spcAft>
+                <a:spcPts val="900"/>
+              </a:spcAft>
+            </a:pPr>
+            <a:r>
+              <a:rPr sz="1600" b="0">
+                <a:solidFill>
+                  <a:srgbClr val="222A35"/>
+                </a:solidFill>
+                <a:latin typeface="Yu Gothic"/>
+                <a:ea typeface="Yu Gothic"/>
+              </a:rPr>
+              <a:t>●  REAL JAPAN VIBES → 海外の日本ファンを獲得</a:t>
+            </a:r>
+          </a:p>
+          <a:p>
+            <a:pPr algn="l">
+              <a:spcAft>
+                <a:spcPts val="900"/>
+              </a:spcAft>
+            </a:pPr>
+            <a:r>
+              <a:rPr sz="1600" b="0">
+                <a:solidFill>
+                  <a:srgbClr val="222A35"/>
+                </a:solidFill>
+                <a:latin typeface="Yu Gothic"/>
+                <a:ea typeface="Yu Gothic"/>
+              </a:rPr>
+              <a:t>●  障がい者施設 → 見込み顧客リストを構築</a:t>
+            </a:r>
+          </a:p>
+        </p:txBody>
+      </p:sp>
+      <p:sp>
+        <p:nvSpPr>
+          <p:cNvPr id="9" name="Rectangle 8"/>
           <p:cNvSpPr/>
           <p:nvPr/>
         </p:nvSpPr>
@@ -8020,7 +8819,7 @@
       </p:sp>
       <p:sp>
         <p:nvSpPr>
-          <p:cNvPr id="9" name="TextBox 8"/>
+          <p:cNvPr id="10" name="TextBox 9"/>
           <p:cNvSpPr txBox="1"/>
           <p:nvPr/>
         </p:nvSpPr>
@@ -8199,7 +8998,7 @@
                 <a:latin typeface="Yu Gothic"/>
                 <a:ea typeface="Yu Gothic"/>
               </a:rPr>
-              <a:t>04 ｜ 実演</a:t>
+              <a:t>04 ｜ WHY</a:t>
             </a:r>
           </a:p>
         </p:txBody>
@@ -8239,7 +9038,7 @@
                 <a:latin typeface="Yu Gothic"/>
                 <a:ea typeface="Yu Gothic"/>
               </a:rPr>
-              <a:t>AI秘書システム実演</a:t>
+              <a:t>なぜSNSなのか</a:t>
             </a:r>
           </a:p>
         </p:txBody>
@@ -8279,7 +9078,7 @@
                 <a:latin typeface="Yu Gothic"/>
                 <a:ea typeface="Yu Gothic"/>
               </a:rPr>
-              <a:t>朝起きて、何を自動化して確認しているか</a:t>
+              <a:t>知られない＝選ばれない。発信しない会社・活動は「無い」のと同じ</a:t>
             </a:r>
           </a:p>
         </p:txBody>
@@ -8469,7 +9268,7 @@
                 <a:latin typeface="Yu Gothic"/>
                 <a:ea typeface="Yu Gothic"/>
               </a:rPr>
-              <a:t>05 ｜ 背景</a:t>
+              <a:t>05 ｜ WHY</a:t>
             </a:r>
           </a:p>
         </p:txBody>
@@ -8509,7 +9308,7 @@
                 <a:latin typeface="Yu Gothic"/>
                 <a:ea typeface="Yu Gothic"/>
               </a:rPr>
-              <a:t>半年で変わったこと</a:t>
+              <a:t>目的から始める</a:t>
             </a:r>
           </a:p>
         </p:txBody>
@@ -8549,7 +9348,7 @@
                 <a:latin typeface="Yu Gothic"/>
                 <a:ea typeface="Yu Gothic"/>
               </a:rPr>
-              <a:t>検索補助から、業務の補佐役へ</a:t>
+              <a:t>目的なき配信は消滅する（議案と同じで“背景と目的”が命）</a:t>
             </a:r>
           </a:p>
         </p:txBody>
@@ -8562,8 +9361,8 @@
         </p:nvSpPr>
         <p:spPr>
           <a:xfrm>
-            <a:off x="1005840" y="2834640"/>
-            <a:ext cx="10058400" cy="3291840"/>
+            <a:off x="1005840" y="2697480"/>
+            <a:ext cx="10058400" cy="3246120"/>
           </a:xfrm>
           <a:prstGeom prst="rect">
             <a:avLst/>
@@ -8578,7 +9377,7 @@
           <a:p>
             <a:pPr algn="l">
               <a:spcAft>
-                <a:spcPts val="1000"/>
+                <a:spcPts val="900"/>
               </a:spcAft>
             </a:pPr>
             <a:r>
@@ -8589,13 +9388,13 @@
                 <a:latin typeface="Yu Gothic"/>
                 <a:ea typeface="Yu Gothic"/>
               </a:rPr>
-              <a:t>●  最初はChatGPTを検索の延長として使っていた</a:t>
-            </a:r>
-          </a:p>
-          <a:p>
-            <a:pPr algn="l">
-              <a:spcAft>
-                <a:spcPts val="1000"/>
+              <a:t>●  理念：なぜやるのか（想い）</a:t>
+            </a:r>
+          </a:p>
+          <a:p>
+            <a:pPr algn="l">
+              <a:spcAft>
+                <a:spcPts val="900"/>
               </a:spcAft>
             </a:pPr>
             <a:r>
@@ -8606,13 +9405,13 @@
                 <a:latin typeface="Yu Gothic"/>
                 <a:ea typeface="Yu Gothic"/>
               </a:rPr>
-              <a:t>●  今年初めの変化でNotebookLM・Claudeを知った</a:t>
-            </a:r>
-          </a:p>
-          <a:p>
-            <a:pPr algn="l">
-              <a:spcAft>
-                <a:spcPts val="1000"/>
+              <a:t>●  目的：何のために</a:t>
+            </a:r>
+          </a:p>
+          <a:p>
+            <a:pPr algn="l">
+              <a:spcAft>
+                <a:spcPts val="900"/>
               </a:spcAft>
             </a:pPr>
             <a:r>
@@ -8623,7 +9422,41 @@
                 <a:latin typeface="Yu Gothic"/>
                 <a:ea typeface="Yu Gothic"/>
               </a:rPr>
-              <a:t>●  時短・自動化・SNS運用・資料作成が一気に進んだ</a:t>
+              <a:t>●  ゴール：どうなれば成功か</a:t>
+            </a:r>
+          </a:p>
+          <a:p>
+            <a:pPr algn="l">
+              <a:spcAft>
+                <a:spcPts val="900"/>
+              </a:spcAft>
+            </a:pPr>
+            <a:r>
+              <a:rPr sz="1600" b="0">
+                <a:solidFill>
+                  <a:srgbClr val="222A35"/>
+                </a:solidFill>
+                <a:latin typeface="Yu Gothic"/>
+                <a:ea typeface="Yu Gothic"/>
+              </a:rPr>
+              <a:t>●  誰のために：価値を届ける相手</a:t>
+            </a:r>
+          </a:p>
+          <a:p>
+            <a:pPr algn="l">
+              <a:spcAft>
+                <a:spcPts val="900"/>
+              </a:spcAft>
+            </a:pPr>
+            <a:r>
+              <a:rPr sz="1600" b="0">
+                <a:solidFill>
+                  <a:srgbClr val="222A35"/>
+                </a:solidFill>
+                <a:latin typeface="Yu Gothic"/>
+                <a:ea typeface="Yu Gothic"/>
+              </a:rPr>
+              <a:t>●  なぜ自社：他でもない自分が発信する理由＝共感の源</a:t>
             </a:r>
           </a:p>
         </p:txBody>
@@ -8897,7 +9730,7 @@
                 <a:latin typeface="Yu Gothic"/>
                 <a:ea typeface="Yu Gothic"/>
               </a:rPr>
-              <a:t>06 ｜ なぜ目的設定</a:t>
+              <a:t>06 ｜ ゴール</a:t>
             </a:r>
           </a:p>
         </p:txBody>
@@ -8937,7 +9770,7 @@
                 <a:latin typeface="Yu Gothic"/>
                 <a:ea typeface="Yu Gothic"/>
               </a:rPr>
-              <a:t>アウトプットしない学びは身につきにくい</a:t>
+              <a:t>本日のゴール</a:t>
             </a:r>
           </a:p>
         </p:txBody>
@@ -8950,8 +9783,8 @@
         </p:nvSpPr>
         <p:spPr>
           <a:xfrm>
-            <a:off x="1005840" y="2834640"/>
-            <a:ext cx="10058400" cy="3291840"/>
+            <a:off x="822960" y="1783080"/>
+            <a:ext cx="10515600" cy="822960"/>
           </a:xfrm>
           <a:prstGeom prst="rect">
             <a:avLst/>
@@ -8966,7 +9799,47 @@
           <a:p>
             <a:pPr algn="l">
               <a:spcAft>
-                <a:spcPts val="1000"/>
+                <a:spcPts val="0"/>
+              </a:spcAft>
+            </a:pPr>
+            <a:r>
+              <a:rPr sz="2000" b="1">
+                <a:solidFill>
+                  <a:srgbClr val="0E1B2E"/>
+                </a:solidFill>
+                <a:latin typeface="Yu Gothic"/>
+                <a:ea typeface="Yu Gothic"/>
+              </a:rPr>
+              <a:t>今日または明日、AIを一つ実践する</a:t>
+            </a:r>
+          </a:p>
+        </p:txBody>
+      </p:sp>
+      <p:sp>
+        <p:nvSpPr>
+          <p:cNvPr id="8" name="TextBox 7"/>
+          <p:cNvSpPr txBox="1"/>
+          <p:nvPr/>
+        </p:nvSpPr>
+        <p:spPr>
+          <a:xfrm>
+            <a:off x="1005840" y="2697480"/>
+            <a:ext cx="10058400" cy="3246120"/>
+          </a:xfrm>
+          <a:prstGeom prst="rect">
+            <a:avLst/>
+          </a:prstGeom>
+          <a:noFill/>
+        </p:spPr>
+        <p:txBody>
+          <a:bodyPr wrap="square" anchor="t" lIns="0" rIns="0" tIns="0" bIns="0">
+            <a:spAutoFit/>
+          </a:bodyPr>
+          <a:lstStyle/>
+          <a:p>
+            <a:pPr algn="l">
+              <a:spcAft>
+                <a:spcPts val="900"/>
               </a:spcAft>
             </a:pPr>
             <a:r>
@@ -8977,13 +9850,13 @@
                 <a:latin typeface="Yu Gothic"/>
                 <a:ea typeface="Yu Gothic"/>
               </a:rPr>
-              <a:t>●  使い方を知るだけなら動画で十分</a:t>
-            </a:r>
-          </a:p>
-          <a:p>
-            <a:pPr algn="l">
-              <a:spcAft>
-                <a:spcPts val="1000"/>
+              <a:t>●  AIに詳しくなる時間ではない</a:t>
+            </a:r>
+          </a:p>
+          <a:p>
+            <a:pPr algn="l">
+              <a:spcAft>
+                <a:spcPts val="900"/>
               </a:spcAft>
             </a:pPr>
             <a:r>
@@ -8994,13 +9867,13 @@
                 <a:latin typeface="Yu Gothic"/>
                 <a:ea typeface="Yu Gothic"/>
               </a:rPr>
-              <a:t>●  使って、誰かに伝えて、初めて力になる</a:t>
-            </a:r>
-          </a:p>
-          <a:p>
-            <a:pPr algn="l">
-              <a:spcAft>
-                <a:spcPts val="1000"/>
+              <a:t>●  明日から一つ、実際に使えるように</a:t>
+            </a:r>
+          </a:p>
+          <a:p>
+            <a:pPr algn="l">
+              <a:spcAft>
+                <a:spcPts val="900"/>
               </a:spcAft>
             </a:pPr>
             <a:r>
@@ -9011,14 +9884,14 @@
                 <a:latin typeface="Yu Gothic"/>
                 <a:ea typeface="Yu Gothic"/>
               </a:rPr>
-              <a:t>●  今日・明日のうちに一つ実行する</a:t>
-            </a:r>
-          </a:p>
-        </p:txBody>
-      </p:sp>
-      <p:sp>
-        <p:nvSpPr>
-          <p:cNvPr id="8" name="Rectangle 7"/>
+              <a:t>●  知っている人ではなく、使った人から変わる</a:t>
+            </a:r>
+          </a:p>
+        </p:txBody>
+      </p:sp>
+      <p:sp>
+        <p:nvSpPr>
+          <p:cNvPr id="9" name="Rectangle 8"/>
           <p:cNvSpPr/>
           <p:nvPr/>
         </p:nvSpPr>
@@ -9062,7 +9935,7 @@
       </p:sp>
       <p:sp>
         <p:nvSpPr>
-          <p:cNvPr id="9" name="TextBox 8"/>
+          <p:cNvPr id="10" name="TextBox 9"/>
           <p:cNvSpPr txBox="1"/>
           <p:nvPr/>
         </p:nvSpPr>
@@ -9133,50 +10006,6 @@
             <a:avLst/>
           </a:prstGeom>
           <a:solidFill>
-            <a:srgbClr val="F7F5EF"/>
-          </a:solidFill>
-          <a:ln>
-            <a:noFill/>
-          </a:ln>
-          <a:effectLst/>
-        </p:spPr>
-        <p:style>
-          <a:lnRef idx="1">
-            <a:schemeClr val="accent1"/>
-          </a:lnRef>
-          <a:fillRef idx="3">
-            <a:schemeClr val="accent1"/>
-          </a:fillRef>
-          <a:effectRef idx="2">
-            <a:schemeClr val="accent1"/>
-          </a:effectRef>
-          <a:fontRef idx="minor">
-            <a:schemeClr val="lt1"/>
-          </a:fontRef>
-        </p:style>
-        <p:txBody>
-          <a:bodyPr rtlCol="0" anchor="ctr"/>
-          <a:lstStyle/>
-          <a:p>
-            <a:pPr algn="ctr"/>
-          </a:p>
-        </p:txBody>
-      </p:sp>
-      <p:sp>
-        <p:nvSpPr>
-          <p:cNvPr id="3" name="Rectangle 2"/>
-          <p:cNvSpPr/>
-          <p:nvPr/>
-        </p:nvSpPr>
-        <p:spPr>
-          <a:xfrm>
-            <a:off x="0" y="0"/>
-            <a:ext cx="12191695" cy="1371600"/>
-          </a:xfrm>
-          <a:prstGeom prst="rect">
-            <a:avLst/>
-          </a:prstGeom>
-          <a:solidFill>
             <a:srgbClr val="0E1B2E"/>
           </a:solidFill>
           <a:ln>
@@ -9208,14 +10037,14 @@
       </p:sp>
       <p:sp>
         <p:nvSpPr>
-          <p:cNvPr id="4" name="Rectangle 3"/>
+          <p:cNvPr id="3" name="Rectangle 2"/>
           <p:cNvSpPr/>
           <p:nvPr/>
         </p:nvSpPr>
         <p:spPr>
           <a:xfrm>
-            <a:off x="0" y="1371600"/>
-            <a:ext cx="12191695" cy="54864"/>
+            <a:off x="822960" y="2148840"/>
+            <a:ext cx="1280160" cy="82296"/>
           </a:xfrm>
           <a:prstGeom prst="rect">
             <a:avLst/>
@@ -9252,14 +10081,14 @@
       </p:sp>
       <p:sp>
         <p:nvSpPr>
-          <p:cNvPr id="5" name="TextBox 4"/>
+          <p:cNvPr id="4" name="TextBox 3"/>
           <p:cNvSpPr txBox="1"/>
           <p:nvPr/>
         </p:nvSpPr>
         <p:spPr>
           <a:xfrm>
-            <a:off x="822960" y="310896"/>
-            <a:ext cx="10515600" cy="365760"/>
+            <a:off x="822960" y="1417320"/>
+            <a:ext cx="10058400" cy="457200"/>
           </a:xfrm>
           <a:prstGeom prst="rect">
             <a:avLst/>
@@ -9278,28 +10107,28 @@
               </a:spcAft>
             </a:pPr>
             <a:r>
-              <a:rPr sz="1300" b="1">
+              <a:rPr sz="1500" b="1">
                 <a:solidFill>
                   <a:srgbClr val="E3C373"/>
                 </a:solidFill>
                 <a:latin typeface="Yu Gothic"/>
                 <a:ea typeface="Yu Gothic"/>
               </a:rPr>
-              <a:t>07 ｜ ブレインアクティベーション</a:t>
-            </a:r>
-          </a:p>
-        </p:txBody>
-      </p:sp>
-      <p:sp>
-        <p:nvSpPr>
-          <p:cNvPr id="6" name="TextBox 5"/>
+              <a:t>07 ｜ 実演</a:t>
+            </a:r>
+          </a:p>
+        </p:txBody>
+      </p:sp>
+      <p:sp>
+        <p:nvSpPr>
+          <p:cNvPr id="5" name="TextBox 4"/>
           <p:cNvSpPr txBox="1"/>
           <p:nvPr/>
         </p:nvSpPr>
         <p:spPr>
           <a:xfrm>
-            <a:off x="822960" y="676656"/>
-            <a:ext cx="10515600" cy="640080"/>
+            <a:off x="822960" y="2423160"/>
+            <a:ext cx="10515600" cy="1554480"/>
           </a:xfrm>
           <a:prstGeom prst="rect">
             <a:avLst/>
@@ -9318,28 +10147,28 @@
               </a:spcAft>
             </a:pPr>
             <a:r>
-              <a:rPr sz="2600" b="1">
+              <a:rPr sz="3400" b="1">
                 <a:solidFill>
                   <a:srgbClr val="FFFFFF"/>
                 </a:solidFill>
                 <a:latin typeface="Yu Gothic"/>
                 <a:ea typeface="Yu Gothic"/>
               </a:rPr>
-              <a:t>今日、何を持ち帰るか</a:t>
-            </a:r>
-          </a:p>
-        </p:txBody>
-      </p:sp>
-      <p:sp>
-        <p:nvSpPr>
-          <p:cNvPr id="7" name="TextBox 6"/>
+              <a:t>AI秘書システム実演</a:t>
+            </a:r>
+          </a:p>
+        </p:txBody>
+      </p:sp>
+      <p:sp>
+        <p:nvSpPr>
+          <p:cNvPr id="6" name="TextBox 5"/>
           <p:cNvSpPr txBox="1"/>
           <p:nvPr/>
         </p:nvSpPr>
         <p:spPr>
           <a:xfrm>
-            <a:off x="1005840" y="2834640"/>
-            <a:ext cx="10058400" cy="3291840"/>
+            <a:off x="822960" y="4206240"/>
+            <a:ext cx="10058400" cy="1371600"/>
           </a:xfrm>
           <a:prstGeom prst="rect">
             <a:avLst/>
@@ -9354,136 +10183,18 @@
           <a:p>
             <a:pPr algn="l">
               <a:spcAft>
-                <a:spcPts val="1000"/>
-              </a:spcAft>
-            </a:pPr>
-            <a:r>
-              <a:rPr sz="1600" b="0">
-                <a:solidFill>
-                  <a:srgbClr val="222A35"/>
-                </a:solidFill>
-                <a:latin typeface="Yu Gothic"/>
-                <a:ea typeface="Yu Gothic"/>
-              </a:rPr>
-              <a:t>●  今日、AIで何を楽にしたい？</a:t>
-            </a:r>
-          </a:p>
-          <a:p>
-            <a:pPr algn="l">
-              <a:spcAft>
-                <a:spcPts val="1000"/>
-              </a:spcAft>
-            </a:pPr>
-            <a:r>
-              <a:rPr sz="1600" b="0">
-                <a:solidFill>
-                  <a:srgbClr val="222A35"/>
-                </a:solidFill>
-                <a:latin typeface="Yu Gothic"/>
-                <a:ea typeface="Yu Gothic"/>
-              </a:rPr>
-              <a:t>●  担当例会・委員会のどこに使えそう？</a:t>
-            </a:r>
-          </a:p>
-          <a:p>
-            <a:pPr algn="l">
-              <a:spcAft>
-                <a:spcPts val="1000"/>
-              </a:spcAft>
-            </a:pPr>
-            <a:r>
-              <a:rPr sz="1600" b="0">
-                <a:solidFill>
-                  <a:srgbClr val="222A35"/>
-                </a:solidFill>
-                <a:latin typeface="Yu Gothic"/>
-                <a:ea typeface="Yu Gothic"/>
-              </a:rPr>
-              <a:t>●  今日学んだことを、誰に伝えたい？</a:t>
-            </a:r>
-          </a:p>
-        </p:txBody>
-      </p:sp>
-      <p:sp>
-        <p:nvSpPr>
-          <p:cNvPr id="8" name="Rectangle 7"/>
-          <p:cNvSpPr/>
-          <p:nvPr/>
-        </p:nvSpPr>
-        <p:spPr>
-          <a:xfrm>
-            <a:off x="0" y="6565392"/>
-            <a:ext cx="12191695" cy="292608"/>
-          </a:xfrm>
-          <a:prstGeom prst="rect">
-            <a:avLst/>
-          </a:prstGeom>
-          <a:solidFill>
-            <a:srgbClr val="0E1B2E"/>
-          </a:solidFill>
-          <a:ln>
-            <a:noFill/>
-          </a:ln>
-          <a:effectLst/>
-        </p:spPr>
-        <p:style>
-          <a:lnRef idx="1">
-            <a:schemeClr val="accent1"/>
-          </a:lnRef>
-          <a:fillRef idx="3">
-            <a:schemeClr val="accent1"/>
-          </a:fillRef>
-          <a:effectRef idx="2">
-            <a:schemeClr val="accent1"/>
-          </a:effectRef>
-          <a:fontRef idx="minor">
-            <a:schemeClr val="lt1"/>
-          </a:fontRef>
-        </p:style>
-        <p:txBody>
-          <a:bodyPr rtlCol="0" anchor="ctr"/>
-          <a:lstStyle/>
-          <a:p>
-            <a:pPr algn="ctr"/>
-          </a:p>
-        </p:txBody>
-      </p:sp>
-      <p:sp>
-        <p:nvSpPr>
-          <p:cNvPr id="9" name="TextBox 8"/>
-          <p:cNvSpPr txBox="1"/>
-          <p:nvPr/>
-        </p:nvSpPr>
-        <p:spPr>
-          <a:xfrm>
-            <a:off x="822960" y="6583680"/>
-            <a:ext cx="10515600" cy="256032"/>
-          </a:xfrm>
-          <a:prstGeom prst="rect">
-            <a:avLst/>
-          </a:prstGeom>
-          <a:noFill/>
-        </p:spPr>
-        <p:txBody>
-          <a:bodyPr wrap="square" anchor="t" lIns="0" rIns="0" tIns="0" bIns="0">
-            <a:spAutoFit/>
-          </a:bodyPr>
-          <a:lstStyle/>
-          <a:p>
-            <a:pPr algn="l">
-              <a:spcAft>
                 <a:spcPts val="0"/>
               </a:spcAft>
             </a:pPr>
             <a:r>
-              <a:rPr sz="1000" b="0">
-                <a:solidFill>
-                  <a:srgbClr val="9FADBD"/>
-                </a:solidFill>
-                <a:latin typeface="Yu Gothic"/>
-                <a:ea typeface="Yu Gothic"/>
-              </a:rPr>
-              <a:t>名古屋JC SNS戦略部会 ｜ AIは、使った人から変わっていく</a:t>
+              <a:rPr sz="1800" b="0">
+                <a:solidFill>
+                  <a:srgbClr val="CDD5DF"/>
+                </a:solidFill>
+                <a:latin typeface="Yu Gothic"/>
+                <a:ea typeface="Yu Gothic"/>
+              </a:rPr>
+              <a:t>朝起きて、何を自動化して確認しているか</a:t>
             </a:r>
           </a:p>
         </p:txBody>
@@ -9673,7 +10384,7 @@
                 <a:latin typeface="Yu Gothic"/>
                 <a:ea typeface="Yu Gothic"/>
               </a:rPr>
-              <a:t>08 ｜ 現在地</a:t>
+              <a:t>08 ｜ 背景</a:t>
             </a:r>
           </a:p>
         </p:txBody>
@@ -9713,7 +10424,7 @@
                 <a:latin typeface="Yu Gothic"/>
                 <a:ea typeface="Yu Gothic"/>
               </a:rPr>
-              <a:t>AI活用の現在地</a:t>
+              <a:t>半年で変わったこと</a:t>
             </a:r>
           </a:p>
         </p:txBody>
@@ -9753,7 +10464,7 @@
                 <a:latin typeface="Yu Gothic"/>
                 <a:ea typeface="Yu Gothic"/>
               </a:rPr>
-              <a:t>役割ごとに使い分ける時代</a:t>
+              <a:t>検索補助から、業務の補佐役へ</a:t>
             </a:r>
           </a:p>
         </p:txBody>
@@ -9766,8 +10477,8 @@
         </p:nvSpPr>
         <p:spPr>
           <a:xfrm>
-            <a:off x="1005840" y="2834640"/>
-            <a:ext cx="10058400" cy="3291840"/>
+            <a:off x="1005840" y="2697480"/>
+            <a:ext cx="10058400" cy="3246120"/>
           </a:xfrm>
           <a:prstGeom prst="rect">
             <a:avLst/>
@@ -9782,7 +10493,7 @@
           <a:p>
             <a:pPr algn="l">
               <a:spcAft>
-                <a:spcPts val="1000"/>
+                <a:spcPts val="900"/>
               </a:spcAft>
             </a:pPr>
             <a:r>
@@ -9793,13 +10504,13 @@
                 <a:latin typeface="Yu Gothic"/>
                 <a:ea typeface="Yu Gothic"/>
               </a:rPr>
-              <a:t>●  ChatGPT：相談・文章・企画・壁打ち</a:t>
-            </a:r>
-          </a:p>
-          <a:p>
-            <a:pPr algn="l">
-              <a:spcAft>
-                <a:spcPts val="1000"/>
+              <a:t>●  最初はChatGPTを検索の延長として使っていた</a:t>
+            </a:r>
+          </a:p>
+          <a:p>
+            <a:pPr algn="l">
+              <a:spcAft>
+                <a:spcPts val="900"/>
               </a:spcAft>
             </a:pPr>
             <a:r>
@@ -9810,13 +10521,13 @@
                 <a:latin typeface="Yu Gothic"/>
                 <a:ea typeface="Yu Gothic"/>
               </a:rPr>
-              <a:t>●  Claude：長文整理・資料構成・自然な文章</a:t>
-            </a:r>
-          </a:p>
-          <a:p>
-            <a:pPr algn="l">
-              <a:spcAft>
-                <a:spcPts val="1000"/>
+              <a:t>●  年初の変化でNotebookLM・Claudeを知った</a:t>
+            </a:r>
+          </a:p>
+          <a:p>
+            <a:pPr algn="l">
+              <a:spcAft>
+                <a:spcPts val="900"/>
               </a:spcAft>
             </a:pPr>
             <a:r>
@@ -9827,24 +10538,7 @@
                 <a:latin typeface="Yu Gothic"/>
                 <a:ea typeface="Yu Gothic"/>
               </a:rPr>
-              <a:t>●  NotebookLM：入れた資料だけで正確に整理</a:t>
-            </a:r>
-          </a:p>
-          <a:p>
-            <a:pPr algn="l">
-              <a:spcAft>
-                <a:spcPts val="1000"/>
-              </a:spcAft>
-            </a:pPr>
-            <a:r>
-              <a:rPr sz="1600" b="0">
-                <a:solidFill>
-                  <a:srgbClr val="222A35"/>
-                </a:solidFill>
-                <a:latin typeface="Yu Gothic"/>
-                <a:ea typeface="Yu Gothic"/>
-              </a:rPr>
-              <a:t>●  画像・動画生成：SNS素材・告知・PR</a:t>
+              <a:t>●  時短・自動化・SNS運用・資料作成が一気に進んだ</a:t>
             </a:r>
           </a:p>
         </p:txBody>
@@ -10118,7 +10812,7 @@
                 <a:latin typeface="Yu Gothic"/>
                 <a:ea typeface="Yu Gothic"/>
               </a:rPr>
-              <a:t>09 ｜ 使い分け</a:t>
+              <a:t>09 ｜ 目的設定</a:t>
             </a:r>
           </a:p>
         </p:txBody>
@@ -10158,7 +10852,7 @@
                 <a:latin typeface="Yu Gothic"/>
                 <a:ea typeface="Yu Gothic"/>
               </a:rPr>
-              <a:t>AIは役割で使い分ける</a:t>
+              <a:t>今日の目的設定</a:t>
             </a:r>
           </a:p>
         </p:txBody>
@@ -10171,8 +10865,8 @@
         </p:nvSpPr>
         <p:spPr>
           <a:xfrm>
-            <a:off x="1005840" y="2834640"/>
-            <a:ext cx="10058400" cy="3291840"/>
+            <a:off x="822960" y="1783080"/>
+            <a:ext cx="10515600" cy="822960"/>
           </a:xfrm>
           <a:prstGeom prst="rect">
             <a:avLst/>
@@ -10187,7 +10881,47 @@
           <a:p>
             <a:pPr algn="l">
               <a:spcAft>
-                <a:spcPts val="1000"/>
+                <a:spcPts val="0"/>
+              </a:spcAft>
+            </a:pPr>
+            <a:r>
+              <a:rPr sz="2000" b="1">
+                <a:solidFill>
+                  <a:srgbClr val="0E1B2E"/>
+                </a:solidFill>
+                <a:latin typeface="Yu Gothic"/>
+                <a:ea typeface="Yu Gothic"/>
+              </a:rPr>
+              <a:t>今日AIで何を楽にしたいか（隣の人と共有）</a:t>
+            </a:r>
+          </a:p>
+        </p:txBody>
+      </p:sp>
+      <p:sp>
+        <p:nvSpPr>
+          <p:cNvPr id="8" name="TextBox 7"/>
+          <p:cNvSpPr txBox="1"/>
+          <p:nvPr/>
+        </p:nvSpPr>
+        <p:spPr>
+          <a:xfrm>
+            <a:off x="1005840" y="2697480"/>
+            <a:ext cx="10058400" cy="3246120"/>
+          </a:xfrm>
+          <a:prstGeom prst="rect">
+            <a:avLst/>
+          </a:prstGeom>
+          <a:noFill/>
+        </p:spPr>
+        <p:txBody>
+          <a:bodyPr wrap="square" anchor="t" lIns="0" rIns="0" tIns="0" bIns="0">
+            <a:spAutoFit/>
+          </a:bodyPr>
+          <a:lstStyle/>
+          <a:p>
+            <a:pPr algn="l">
+              <a:spcAft>
+                <a:spcPts val="900"/>
               </a:spcAft>
             </a:pPr>
             <a:r>
@@ -10198,13 +10932,13 @@
                 <a:latin typeface="Yu Gothic"/>
                 <a:ea typeface="Yu Gothic"/>
               </a:rPr>
-              <a:t>●  秘書：予定・タスク・連絡の整理</a:t>
-            </a:r>
-          </a:p>
-          <a:p>
-            <a:pPr algn="l">
-              <a:spcAft>
-                <a:spcPts val="1000"/>
+              <a:t>●  担当例会・委員会のどこに使える？</a:t>
+            </a:r>
+          </a:p>
+          <a:p>
+            <a:pPr algn="l">
+              <a:spcAft>
+                <a:spcPts val="900"/>
               </a:spcAft>
             </a:pPr>
             <a:r>
@@ -10215,13 +10949,13 @@
                 <a:latin typeface="Yu Gothic"/>
                 <a:ea typeface="Yu Gothic"/>
               </a:rPr>
-              <a:t>●  編集者：文章を整える</a:t>
-            </a:r>
-          </a:p>
-          <a:p>
-            <a:pPr algn="l">
-              <a:spcAft>
-                <a:spcPts val="1000"/>
+              <a:t>●  SNS・資料・議事録・案内文・企画書？</a:t>
+            </a:r>
+          </a:p>
+          <a:p>
+            <a:pPr algn="l">
+              <a:spcAft>
+                <a:spcPts val="900"/>
               </a:spcAft>
             </a:pPr>
             <a:r>
@@ -10232,31 +10966,14 @@
                 <a:latin typeface="Yu Gothic"/>
                 <a:ea typeface="Yu Gothic"/>
               </a:rPr>
-              <a:t>●  広報担当：投稿・告知を作る</a:t>
-            </a:r>
-          </a:p>
-          <a:p>
-            <a:pPr algn="l">
-              <a:spcAft>
-                <a:spcPts val="1000"/>
-              </a:spcAft>
-            </a:pPr>
-            <a:r>
-              <a:rPr sz="1600" b="0">
-                <a:solidFill>
-                  <a:srgbClr val="222A35"/>
-                </a:solidFill>
-                <a:latin typeface="Yu Gothic"/>
-                <a:ea typeface="Yu Gothic"/>
-              </a:rPr>
-              <a:t>●  企画補佐／壁打ち相手：アイデアを広げる</a:t>
-            </a:r>
-          </a:p>
-        </p:txBody>
-      </p:sp>
-      <p:sp>
-        <p:nvSpPr>
-          <p:cNvPr id="8" name="Rectangle 7"/>
+              <a:t>●  今日学んだことを、誰に伝えたい？</a:t>
+            </a:r>
+          </a:p>
+        </p:txBody>
+      </p:sp>
+      <p:sp>
+        <p:nvSpPr>
+          <p:cNvPr id="9" name="Rectangle 8"/>
           <p:cNvSpPr/>
           <p:nvPr/>
         </p:nvSpPr>
@@ -10300,7 +11017,7 @@
       </p:sp>
       <p:sp>
         <p:nvSpPr>
-          <p:cNvPr id="9" name="TextBox 8"/>
+          <p:cNvPr id="10" name="TextBox 9"/>
           <p:cNvSpPr txBox="1"/>
           <p:nvPr/>
         </p:nvSpPr>

</xml_diff>

<commit_message>
De-identify account/brand names across materials
- Seminar files + deck (.pptx): genericize 実績 (removed うなぎのぼり/REAL JAPAN VIBES/
  グループホーム/インバウンドサミット → generic business types).
- Ch.5 rewritten generically (6役割の設計図, no account count, no brand names).
- Ch.4 TikTok自動化 example de-identified; Ch.1 removed account counts.
</commit_message>
<xml_diff>
--- a/ai_sns_seminar_deck.pptx
+++ b/ai_sns_seminar_deck.pptx
@@ -8683,7 +8683,7 @@
                 <a:latin typeface="Yu Gothic"/>
                 <a:ea typeface="Yu Gothic"/>
               </a:rPr>
-              <a:t>●  鰻の通販「うなぎのぼり」を運営</a:t>
+              <a:t>●  ネットショップ（通販）をSNS発信で運営</a:t>
             </a:r>
           </a:p>
           <a:p>
@@ -8751,7 +8751,7 @@
                 <a:latin typeface="Yu Gothic"/>
                 <a:ea typeface="Yu Gothic"/>
               </a:rPr>
-              <a:t>●  REAL JAPAN VIBES → 海外の日本ファンを獲得</a:t>
+              <a:t>●  海外向けSNS発信 → 海外の日本ファンを獲得</a:t>
             </a:r>
           </a:p>
           <a:p>
@@ -8768,7 +8768,7 @@
                 <a:latin typeface="Yu Gothic"/>
                 <a:ea typeface="Yu Gothic"/>
               </a:rPr>
-              <a:t>●  障がい者施設 → 見込み顧客リストを構築</a:t>
+              <a:t>●  福祉分野 → 見込み顧客リストを構築</a:t>
             </a:r>
           </a:p>
         </p:txBody>

</xml_diff>